<commit_message>
Añade diapo 6: diagrama del DiD de Gillmore (cohortes × olas × edades)
Filas tratado/control con barras de vida, bandas de ola 2012/2017/2024,
línea del 27-F, edades en cada medición, cruces de no-re-entrevistados en
2024 y tarjetas corto/mediano/largo plazo.

Co-Authored-By: Claude Fable 5 <noreply@anthropic.com>
Claude-Session: https://claude.ai/code/session_01UqKvCdoWhpNY2WRQ7PFfps
</commit_message>
<xml_diff>
--- a/docs/presentacion_elpi_gillmore.pptx
+++ b/docs/presentacion_elpi_gillmore.pptx
@@ -10,9 +10,10 @@
     <p:sldId id="258" r:id="rId4"/>
     <p:sldId id="259" r:id="rId5"/>
     <p:sldId id="260" r:id="rId6"/>
+    <p:sldId id="261" r:id="rId7"/>
   </p:sldIdLst>
   <p:notesMasterIdLst>
-    <p:notesMasterId r:id="rId7"/>
+    <p:notesMasterId r:id="rId8"/>
   </p:notesMasterIdLst>
   <p:sldSz cx="12192000" cy="6858000"/>
   <p:notesSz cx="6858000" cy="12192000"/>
@@ -882,6 +883,94 @@
             <a:fld id="{F7021451-1387-4CA6-816F-3879F97B5CBC}" type="slidenum">
               <a:rPr lang="en-US"/>
               <a:t>5</a:t>
+            </a:fld>
+            <a:endParaRPr lang="en-US"/>
+          </a:p>
+        </p:txBody>
+      </p:sp>
+    </p:spTree>
+    <p:extLst>
+      <p:ext uri="{BB962C8B-B14F-4D97-AF65-F5344CB8AC3E}">
+        <p14:creationId xmlns:p14="http://schemas.microsoft.com/office/powerpoint/2010/main" val="1024086991"/>
+      </p:ext>
+    </p:extLst>
+  </p:cSld>
+  <p:clrMapOvr>
+    <a:masterClrMapping/>
+  </p:clrMapOvr>
+</p:notes>
+</file>
+
+<file path=ppt/notesSlides/notesSlide6.xml><?xml version="1.0" encoding="utf-8"?>
+<p:notes xmlns:a="http://schemas.openxmlformats.org/drawingml/2006/main" xmlns:r="http://schemas.openxmlformats.org/officeDocument/2006/relationships" xmlns:p="http://schemas.openxmlformats.org/presentationml/2006/main">
+  <p:cSld>
+    <p:spTree>
+      <p:nvGrpSpPr>
+        <p:cNvPr id="1" name=""/>
+        <p:cNvGrpSpPr/>
+        <p:nvPr/>
+      </p:nvGrpSpPr>
+      <p:grpSpPr>
+        <a:xfrm>
+          <a:off x="0" y="0"/>
+          <a:ext cx="0" cy="0"/>
+          <a:chOff x="0" y="0"/>
+          <a:chExt cx="0" cy="0"/>
+        </a:xfrm>
+      </p:grpSpPr>
+      <p:sp>
+        <p:nvSpPr>
+          <p:cNvPr id="2" name="Slide Image Placeholder 1"/>
+          <p:cNvSpPr>
+            <a:spLocks noGrp="1" noRot="1" noChangeAspect="1"/>
+          </p:cNvSpPr>
+          <p:nvPr>
+            <p:ph type="sldImg"/>
+          </p:nvPr>
+        </p:nvSpPr>
+        <p:spPr/>
+      </p:sp>
+      <p:sp>
+        <p:nvSpPr>
+          <p:cNvPr id="3" name="Notes Placeholder 2"/>
+          <p:cNvSpPr>
+            <a:spLocks noGrp="1"/>
+          </p:cNvSpPr>
+          <p:nvPr>
+            <p:ph type="body" idx="1"/>
+          </p:nvPr>
+        </p:nvSpPr>
+        <p:spPr/>
+        <p:txBody>
+          <a:bodyPr/>
+          <a:lstStyle/>
+          <a:p>
+            <a:r>
+              <a:rPr lang="en-US" dirty="0"/>
+              <a:t>Diagrama del diseno de Gillmore: fila tratada (2006-nov2010) medida en 2012 (2-6, corto), 2017 (7-11, mediano) y 2024 (14-18, largo); filas de control nacidas post-27F via refrescos, medidas en 2017 y NO re-entrevistadas en 2024; banda roja = 27-F.</a:t>
+            </a:r>
+            <a:endParaRPr lang="en-US" dirty="0"/>
+          </a:p>
+        </p:txBody>
+      </p:sp>
+      <p:sp>
+        <p:nvSpPr>
+          <p:cNvPr id="4" name="Slide Number Placeholder 3"/>
+          <p:cNvSpPr>
+            <a:spLocks noGrp="1"/>
+          </p:cNvSpPr>
+          <p:nvPr>
+            <p:ph type="sldNum" sz="quarter" idx="10"/>
+          </p:nvPr>
+        </p:nvSpPr>
+        <p:spPr/>
+        <p:txBody>
+          <a:bodyPr/>
+          <a:lstStyle/>
+          <a:p>
+            <a:fld id="{F7021451-1387-4CA6-816F-3879F97B5CBC}" type="slidenum">
+              <a:rPr lang="en-US"/>
+              <a:t>6</a:t>
             </a:fld>
             <a:endParaRPr lang="en-US"/>
           </a:p>
@@ -8233,6 +8322,1653 @@
 </p:sld>
 </file>
 
+<file path=ppt/slides/slide6.xml><?xml version="1.0" encoding="utf-8"?>
+<p:sld xmlns:a="http://schemas.openxmlformats.org/drawingml/2006/main" xmlns:r="http://schemas.openxmlformats.org/officeDocument/2006/relationships" xmlns:p="http://schemas.openxmlformats.org/presentationml/2006/main">
+  <p:cSld name="Slide 6">
+    <p:bg>
+      <p:bgPr>
+        <a:solidFill>
+          <a:srgbClr val="FFFFFF"/>
+        </a:solidFill>
+      </p:bgPr>
+    </p:bg>
+    <p:spTree>
+      <p:nvGrpSpPr>
+        <p:cNvPr id="1" name=""/>
+        <p:cNvGrpSpPr/>
+        <p:nvPr/>
+      </p:nvGrpSpPr>
+      <p:grpSpPr>
+        <a:xfrm>
+          <a:off x="0" y="0"/>
+          <a:ext cx="0" cy="0"/>
+          <a:chOff x="0" y="0"/>
+          <a:chExt cx="0" cy="0"/>
+        </a:xfrm>
+      </p:grpSpPr>
+      <p:sp>
+        <p:nvSpPr>
+          <p:cNvPr id="2" name="Text 0"/>
+          <p:cNvSpPr txBox="1"/>
+          <p:nvPr/>
+        </p:nvSpPr>
+        <p:spPr>
+          <a:xfrm>
+            <a:off x="457200" y="237744"/>
+            <a:ext cx="11274552" cy="493776"/>
+          </a:xfrm>
+          <a:prstGeom prst="rect">
+            <a:avLst/>
+          </a:prstGeom>
+          <a:noFill/>
+          <a:ln/>
+        </p:spPr>
+        <p:txBody>
+          <a:bodyPr wrap="square" lIns="0" tIns="0" rIns="0" bIns="0" rtlCol="0" anchor="ctr"/>
+          <a:lstStyle/>
+          <a:p>
+            <a:pPr algn="l" indent="0" marL="0">
+              <a:buNone/>
+            </a:pPr>
+            <a:r>
+              <a:rPr lang="en-US" sz="3000" b="1" dirty="0">
+                <a:solidFill>
+                  <a:srgbClr val="0B0B0B"/>
+                </a:solidFill>
+                <a:latin typeface="Cambria" pitchFamily="34" charset="0"/>
+                <a:ea typeface="Cambria" pitchFamily="34" charset="-122"/>
+                <a:cs typeface="Cambria" pitchFamily="34" charset="-120"/>
+              </a:rPr>
+              <a:t>El DiD de Gillmore: cohortes, olas y edades</a:t>
+            </a:r>
+            <a:endParaRPr lang="en-US" sz="3000" dirty="0"/>
+          </a:p>
+        </p:txBody>
+      </p:sp>
+      <p:sp>
+        <p:nvSpPr>
+          <p:cNvPr id="3" name="Text 1"/>
+          <p:cNvSpPr txBox="1"/>
+          <p:nvPr/>
+        </p:nvSpPr>
+        <p:spPr>
+          <a:xfrm>
+            <a:off x="457200" y="786384"/>
+            <a:ext cx="11274552" cy="292608"/>
+          </a:xfrm>
+          <a:prstGeom prst="rect">
+            <a:avLst/>
+          </a:prstGeom>
+          <a:noFill/>
+          <a:ln/>
+        </p:spPr>
+        <p:txBody>
+          <a:bodyPr wrap="square" lIns="0" tIns="0" rIns="0" bIns="0" rtlCol="0" anchor="ctr"/>
+          <a:lstStyle/>
+          <a:p>
+            <a:pPr algn="l" indent="0" marL="0">
+              <a:buNone/>
+            </a:pPr>
+            <a:r>
+              <a:rPr lang="en-US" sz="1150" dirty="0">
+                <a:solidFill>
+                  <a:srgbClr val="52514E"/>
+                </a:solidFill>
+                <a:latin typeface="Arial" pitchFamily="34" charset="0"/>
+                <a:ea typeface="Arial" pitchFamily="34" charset="-122"/>
+                <a:cs typeface="Arial" pitchFamily="34" charset="-120"/>
+              </a:rPr>
+              <a:t>Affected = 1 si el niño tenía 0–4 años (o estaba en gestación) el 27-F. El grupo de control —concebidos después— solo existe gracias a los refrescos… y no fue re-entrevistado en 2024.</a:t>
+            </a:r>
+            <a:endParaRPr lang="en-US" sz="1150" dirty="0"/>
+          </a:p>
+        </p:txBody>
+      </p:sp>
+      <p:sp>
+        <p:nvSpPr>
+          <p:cNvPr id="4" name="Shape 2"/>
+          <p:cNvSpPr/>
+          <p:nvPr/>
+        </p:nvSpPr>
+        <p:spPr>
+          <a:xfrm>
+            <a:off x="5366796" y="1444752"/>
+            <a:ext cx="603504" cy="3054096"/>
+          </a:xfrm>
+          <a:prstGeom prst="roundRect">
+            <a:avLst>
+              <a:gd name="adj" fmla="val 7576"/>
+            </a:avLst>
+          </a:prstGeom>
+          <a:solidFill>
+            <a:srgbClr val="EDF3FC"/>
+          </a:solidFill>
+          <a:ln/>
+        </p:spPr>
+      </p:sp>
+      <p:sp>
+        <p:nvSpPr>
+          <p:cNvPr id="5" name="Text 3"/>
+          <p:cNvSpPr txBox="1"/>
+          <p:nvPr/>
+        </p:nvSpPr>
+        <p:spPr>
+          <a:xfrm>
+            <a:off x="5028468" y="1207008"/>
+            <a:ext cx="1280160" cy="201168"/>
+          </a:xfrm>
+          <a:prstGeom prst="rect">
+            <a:avLst/>
+          </a:prstGeom>
+          <a:noFill/>
+          <a:ln/>
+        </p:spPr>
+        <p:txBody>
+          <a:bodyPr wrap="square" lIns="0" tIns="0" rIns="0" bIns="0" rtlCol="0" anchor="ctr"/>
+          <a:lstStyle/>
+          <a:p>
+            <a:pPr algn="ctr" indent="0" marL="0">
+              <a:buNone/>
+            </a:pPr>
+            <a:r>
+              <a:rPr lang="en-US" sz="950" b="1" dirty="0">
+                <a:solidFill>
+                  <a:srgbClr val="1E3D5C"/>
+                </a:solidFill>
+                <a:latin typeface="Arial" pitchFamily="34" charset="0"/>
+                <a:ea typeface="Arial" pitchFamily="34" charset="-122"/>
+                <a:cs typeface="Arial" pitchFamily="34" charset="-120"/>
+              </a:rPr>
+              <a:t>OLA 2012</a:t>
+            </a:r>
+            <a:endParaRPr lang="en-US" sz="950" dirty="0"/>
+          </a:p>
+        </p:txBody>
+      </p:sp>
+      <p:sp>
+        <p:nvSpPr>
+          <p:cNvPr id="6" name="Shape 4"/>
+          <p:cNvSpPr/>
+          <p:nvPr/>
+        </p:nvSpPr>
+        <p:spPr>
+          <a:xfrm>
+            <a:off x="7723662" y="1444752"/>
+            <a:ext cx="603504" cy="3054096"/>
+          </a:xfrm>
+          <a:prstGeom prst="roundRect">
+            <a:avLst>
+              <a:gd name="adj" fmla="val 7576"/>
+            </a:avLst>
+          </a:prstGeom>
+          <a:solidFill>
+            <a:srgbClr val="EDF3FC"/>
+          </a:solidFill>
+          <a:ln/>
+        </p:spPr>
+      </p:sp>
+      <p:sp>
+        <p:nvSpPr>
+          <p:cNvPr id="7" name="Text 5"/>
+          <p:cNvSpPr txBox="1"/>
+          <p:nvPr/>
+        </p:nvSpPr>
+        <p:spPr>
+          <a:xfrm>
+            <a:off x="7385334" y="1207008"/>
+            <a:ext cx="1280160" cy="201168"/>
+          </a:xfrm>
+          <a:prstGeom prst="rect">
+            <a:avLst/>
+          </a:prstGeom>
+          <a:noFill/>
+          <a:ln/>
+        </p:spPr>
+        <p:txBody>
+          <a:bodyPr wrap="square" lIns="0" tIns="0" rIns="0" bIns="0" rtlCol="0" anchor="ctr"/>
+          <a:lstStyle/>
+          <a:p>
+            <a:pPr algn="ctr" indent="0" marL="0">
+              <a:buNone/>
+            </a:pPr>
+            <a:r>
+              <a:rPr lang="en-US" sz="950" b="1" dirty="0">
+                <a:solidFill>
+                  <a:srgbClr val="1E3D5C"/>
+                </a:solidFill>
+                <a:latin typeface="Arial" pitchFamily="34" charset="0"/>
+                <a:ea typeface="Arial" pitchFamily="34" charset="-122"/>
+                <a:cs typeface="Arial" pitchFamily="34" charset="-120"/>
+              </a:rPr>
+              <a:t>OLA 2017</a:t>
+            </a:r>
+            <a:endParaRPr lang="en-US" sz="950" dirty="0"/>
+          </a:p>
+        </p:txBody>
+      </p:sp>
+      <p:sp>
+        <p:nvSpPr>
+          <p:cNvPr id="8" name="Shape 6"/>
+          <p:cNvSpPr/>
+          <p:nvPr/>
+        </p:nvSpPr>
+        <p:spPr>
+          <a:xfrm>
+            <a:off x="10976138" y="1444752"/>
+            <a:ext cx="603504" cy="3054096"/>
+          </a:xfrm>
+          <a:prstGeom prst="roundRect">
+            <a:avLst>
+              <a:gd name="adj" fmla="val 7576"/>
+            </a:avLst>
+          </a:prstGeom>
+          <a:solidFill>
+            <a:srgbClr val="EDF3FC"/>
+          </a:solidFill>
+          <a:ln/>
+        </p:spPr>
+      </p:sp>
+      <p:sp>
+        <p:nvSpPr>
+          <p:cNvPr id="9" name="Text 7"/>
+          <p:cNvSpPr txBox="1"/>
+          <p:nvPr/>
+        </p:nvSpPr>
+        <p:spPr>
+          <a:xfrm>
+            <a:off x="10637810" y="1207008"/>
+            <a:ext cx="1280160" cy="201168"/>
+          </a:xfrm>
+          <a:prstGeom prst="rect">
+            <a:avLst/>
+          </a:prstGeom>
+          <a:noFill/>
+          <a:ln/>
+        </p:spPr>
+        <p:txBody>
+          <a:bodyPr wrap="square" lIns="0" tIns="0" rIns="0" bIns="0" rtlCol="0" anchor="ctr"/>
+          <a:lstStyle/>
+          <a:p>
+            <a:pPr algn="ctr" indent="0" marL="0">
+              <a:buNone/>
+            </a:pPr>
+            <a:r>
+              <a:rPr lang="en-US" sz="950" b="1" dirty="0">
+                <a:solidFill>
+                  <a:srgbClr val="1E3D5C"/>
+                </a:solidFill>
+                <a:latin typeface="Arial" pitchFamily="34" charset="0"/>
+                <a:ea typeface="Arial" pitchFamily="34" charset="-122"/>
+                <a:cs typeface="Arial" pitchFamily="34" charset="-120"/>
+              </a:rPr>
+              <a:t>OLA 2024</a:t>
+            </a:r>
+            <a:endParaRPr lang="en-US" sz="950" dirty="0"/>
+          </a:p>
+        </p:txBody>
+      </p:sp>
+      <p:sp>
+        <p:nvSpPr>
+          <p:cNvPr id="10" name="Shape 8"/>
+          <p:cNvSpPr/>
+          <p:nvPr/>
+        </p:nvSpPr>
+        <p:spPr>
+          <a:xfrm>
+            <a:off x="4594243" y="1371600"/>
+            <a:ext cx="27432" cy="3200400"/>
+          </a:xfrm>
+          <a:prstGeom prst="rect">
+            <a:avLst/>
+          </a:prstGeom>
+          <a:solidFill>
+            <a:srgbClr val="C0392B"/>
+          </a:solidFill>
+          <a:ln/>
+        </p:spPr>
+      </p:sp>
+      <p:sp>
+        <p:nvSpPr>
+          <p:cNvPr id="11" name="Text 9"/>
+          <p:cNvSpPr txBox="1"/>
+          <p:nvPr/>
+        </p:nvSpPr>
+        <p:spPr>
+          <a:xfrm>
+            <a:off x="3876439" y="1005840"/>
+            <a:ext cx="1463040" cy="182880"/>
+          </a:xfrm>
+          <a:prstGeom prst="rect">
+            <a:avLst/>
+          </a:prstGeom>
+          <a:noFill/>
+          <a:ln/>
+        </p:spPr>
+        <p:txBody>
+          <a:bodyPr wrap="square" lIns="0" tIns="0" rIns="0" bIns="0" rtlCol="0" anchor="ctr"/>
+          <a:lstStyle/>
+          <a:p>
+            <a:pPr algn="ctr" indent="0" marL="0">
+              <a:buNone/>
+            </a:pPr>
+            <a:r>
+              <a:rPr lang="en-US" sz="950" b="1" dirty="0">
+                <a:solidFill>
+                  <a:srgbClr val="C0392B"/>
+                </a:solidFill>
+                <a:latin typeface="Arial" pitchFamily="34" charset="0"/>
+                <a:ea typeface="Arial" pitchFamily="34" charset="-122"/>
+                <a:cs typeface="Arial" pitchFamily="34" charset="-120"/>
+              </a:rPr>
+              <a:t>27-F (8,8 Mw)</a:t>
+            </a:r>
+            <a:endParaRPr lang="en-US" sz="950" dirty="0"/>
+          </a:p>
+        </p:txBody>
+      </p:sp>
+      <p:sp>
+        <p:nvSpPr>
+          <p:cNvPr id="12" name="Shape 10"/>
+          <p:cNvSpPr/>
+          <p:nvPr/>
+        </p:nvSpPr>
+        <p:spPr>
+          <a:xfrm>
+            <a:off x="2651760" y="1828800"/>
+            <a:ext cx="9006840" cy="274320"/>
+          </a:xfrm>
+          <a:prstGeom prst="roundRect">
+            <a:avLst>
+              <a:gd name="adj" fmla="val 26667"/>
+            </a:avLst>
+          </a:prstGeom>
+          <a:solidFill>
+            <a:srgbClr val="CFE0F6"/>
+          </a:solidFill>
+          <a:ln w="12700">
+            <a:solidFill>
+              <a:srgbClr val="2A78D6"/>
+            </a:solidFill>
+            <a:prstDash val="solid"/>
+          </a:ln>
+        </p:spPr>
+      </p:sp>
+      <p:sp>
+        <p:nvSpPr>
+          <p:cNvPr id="13" name="Text 11"/>
+          <p:cNvSpPr txBox="1"/>
+          <p:nvPr/>
+        </p:nvSpPr>
+        <p:spPr>
+          <a:xfrm>
+            <a:off x="457200" y="1691640"/>
+            <a:ext cx="2103120" cy="182880"/>
+          </a:xfrm>
+          <a:prstGeom prst="rect">
+            <a:avLst/>
+          </a:prstGeom>
+          <a:noFill/>
+          <a:ln/>
+        </p:spPr>
+        <p:txBody>
+          <a:bodyPr wrap="square" lIns="0" tIns="0" rIns="0" bIns="0" rtlCol="0" anchor="ctr"/>
+          <a:lstStyle/>
+          <a:p>
+            <a:pPr algn="l" indent="0" marL="0">
+              <a:buNone/>
+            </a:pPr>
+            <a:r>
+              <a:rPr lang="en-US" sz="950" b="1" dirty="0">
+                <a:solidFill>
+                  <a:srgbClr val="0B0B0B"/>
+                </a:solidFill>
+                <a:latin typeface="Arial" pitchFamily="34" charset="0"/>
+                <a:ea typeface="Arial" pitchFamily="34" charset="-122"/>
+                <a:cs typeface="Arial" pitchFamily="34" charset="-120"/>
+              </a:rPr>
+              <a:t>AFFECTED = 1</a:t>
+            </a:r>
+            <a:endParaRPr lang="en-US" sz="950" dirty="0"/>
+          </a:p>
+        </p:txBody>
+      </p:sp>
+      <p:sp>
+        <p:nvSpPr>
+          <p:cNvPr id="14" name="Text 12"/>
+          <p:cNvSpPr txBox="1"/>
+          <p:nvPr/>
+        </p:nvSpPr>
+        <p:spPr>
+          <a:xfrm>
+            <a:off x="457200" y="1883664"/>
+            <a:ext cx="2103120" cy="384048"/>
+          </a:xfrm>
+          <a:prstGeom prst="rect">
+            <a:avLst/>
+          </a:prstGeom>
+          <a:noFill/>
+          <a:ln/>
+        </p:spPr>
+        <p:txBody>
+          <a:bodyPr wrap="square" lIns="0" tIns="0" rIns="0" bIns="0" rtlCol="0" anchor="ctr"/>
+          <a:lstStyle/>
+          <a:p>
+            <a:pPr algn="l" indent="0" marL="0">
+              <a:buNone/>
+            </a:pPr>
+            <a:r>
+              <a:rPr lang="en-US" sz="800" dirty="0">
+                <a:solidFill>
+                  <a:srgbClr val="52514E"/>
+                </a:solidFill>
+                <a:latin typeface="Arial" pitchFamily="34" charset="0"/>
+                <a:ea typeface="Arial" pitchFamily="34" charset="-122"/>
+                <a:cs typeface="Arial" pitchFamily="34" charset="-120"/>
+              </a:rPr>
+              <a:t>Nacidos 2006–nov 2010: 0–4 años el 27-F (los de mar–nov 2010 entran vía refresco 2012)</a:t>
+            </a:r>
+            <a:endParaRPr lang="en-US" sz="800" dirty="0"/>
+          </a:p>
+        </p:txBody>
+      </p:sp>
+      <p:sp>
+        <p:nvSpPr>
+          <p:cNvPr id="15" name="Shape 13"/>
+          <p:cNvSpPr/>
+          <p:nvPr/>
+        </p:nvSpPr>
+        <p:spPr>
+          <a:xfrm>
+            <a:off x="5540532" y="1837944"/>
+            <a:ext cx="256032" cy="256032"/>
+          </a:xfrm>
+          <a:prstGeom prst="ellipse">
+            <a:avLst/>
+          </a:prstGeom>
+          <a:solidFill>
+            <a:srgbClr val="2A78D6"/>
+          </a:solidFill>
+          <a:ln w="19050">
+            <a:solidFill>
+              <a:srgbClr val="FFFFFF"/>
+            </a:solidFill>
+            <a:prstDash val="solid"/>
+          </a:ln>
+        </p:spPr>
+      </p:sp>
+      <p:sp>
+        <p:nvSpPr>
+          <p:cNvPr id="16" name="Text 14"/>
+          <p:cNvSpPr txBox="1"/>
+          <p:nvPr/>
+        </p:nvSpPr>
+        <p:spPr>
+          <a:xfrm>
+            <a:off x="5165628" y="1536192"/>
+            <a:ext cx="1005840" cy="182880"/>
+          </a:xfrm>
+          <a:prstGeom prst="rect">
+            <a:avLst/>
+          </a:prstGeom>
+          <a:noFill/>
+          <a:ln/>
+        </p:spPr>
+        <p:txBody>
+          <a:bodyPr wrap="square" lIns="0" tIns="0" rIns="0" bIns="0" rtlCol="0" anchor="ctr"/>
+          <a:lstStyle/>
+          <a:p>
+            <a:pPr algn="ctr" indent="0" marL="0">
+              <a:buNone/>
+            </a:pPr>
+            <a:r>
+              <a:rPr lang="en-US" sz="1000" b="1" dirty="0">
+                <a:solidFill>
+                  <a:srgbClr val="1E3D5C"/>
+                </a:solidFill>
+                <a:latin typeface="Arial" pitchFamily="34" charset="0"/>
+                <a:ea typeface="Arial" pitchFamily="34" charset="-122"/>
+                <a:cs typeface="Arial" pitchFamily="34" charset="-120"/>
+              </a:rPr>
+              <a:t>2–6</a:t>
+            </a:r>
+            <a:endParaRPr lang="en-US" sz="1000" dirty="0"/>
+          </a:p>
+        </p:txBody>
+      </p:sp>
+      <p:sp>
+        <p:nvSpPr>
+          <p:cNvPr id="17" name="Text 15"/>
+          <p:cNvSpPr txBox="1"/>
+          <p:nvPr/>
+        </p:nvSpPr>
+        <p:spPr>
+          <a:xfrm>
+            <a:off x="5119908" y="2148840"/>
+            <a:ext cx="1097280" cy="164592"/>
+          </a:xfrm>
+          <a:prstGeom prst="rect">
+            <a:avLst/>
+          </a:prstGeom>
+          <a:noFill/>
+          <a:ln/>
+        </p:spPr>
+        <p:txBody>
+          <a:bodyPr wrap="square" lIns="0" tIns="0" rIns="0" bIns="0" rtlCol="0" anchor="ctr"/>
+          <a:lstStyle/>
+          <a:p>
+            <a:pPr algn="ctr" indent="0" marL="0">
+              <a:buNone/>
+            </a:pPr>
+            <a:r>
+              <a:rPr lang="en-US" sz="800" dirty="0">
+                <a:solidFill>
+                  <a:srgbClr val="898781"/>
+                </a:solidFill>
+                <a:latin typeface="Arial" pitchFamily="34" charset="0"/>
+                <a:ea typeface="Arial" pitchFamily="34" charset="-122"/>
+                <a:cs typeface="Arial" pitchFamily="34" charset="-120"/>
+              </a:rPr>
+              <a:t>corto plazo</a:t>
+            </a:r>
+            <a:endParaRPr lang="en-US" sz="800" dirty="0"/>
+          </a:p>
+        </p:txBody>
+      </p:sp>
+      <p:sp>
+        <p:nvSpPr>
+          <p:cNvPr id="18" name="Shape 16"/>
+          <p:cNvSpPr/>
+          <p:nvPr/>
+        </p:nvSpPr>
+        <p:spPr>
+          <a:xfrm>
+            <a:off x="7897398" y="1837944"/>
+            <a:ext cx="256032" cy="256032"/>
+          </a:xfrm>
+          <a:prstGeom prst="ellipse">
+            <a:avLst/>
+          </a:prstGeom>
+          <a:solidFill>
+            <a:srgbClr val="2A78D6"/>
+          </a:solidFill>
+          <a:ln w="19050">
+            <a:solidFill>
+              <a:srgbClr val="FFFFFF"/>
+            </a:solidFill>
+            <a:prstDash val="solid"/>
+          </a:ln>
+        </p:spPr>
+      </p:sp>
+      <p:sp>
+        <p:nvSpPr>
+          <p:cNvPr id="19" name="Text 17"/>
+          <p:cNvSpPr txBox="1"/>
+          <p:nvPr/>
+        </p:nvSpPr>
+        <p:spPr>
+          <a:xfrm>
+            <a:off x="7522494" y="1536192"/>
+            <a:ext cx="1005840" cy="182880"/>
+          </a:xfrm>
+          <a:prstGeom prst="rect">
+            <a:avLst/>
+          </a:prstGeom>
+          <a:noFill/>
+          <a:ln/>
+        </p:spPr>
+        <p:txBody>
+          <a:bodyPr wrap="square" lIns="0" tIns="0" rIns="0" bIns="0" rtlCol="0" anchor="ctr"/>
+          <a:lstStyle/>
+          <a:p>
+            <a:pPr algn="ctr" indent="0" marL="0">
+              <a:buNone/>
+            </a:pPr>
+            <a:r>
+              <a:rPr lang="en-US" sz="1000" b="1" dirty="0">
+                <a:solidFill>
+                  <a:srgbClr val="1E3D5C"/>
+                </a:solidFill>
+                <a:latin typeface="Arial" pitchFamily="34" charset="0"/>
+                <a:ea typeface="Arial" pitchFamily="34" charset="-122"/>
+                <a:cs typeface="Arial" pitchFamily="34" charset="-120"/>
+              </a:rPr>
+              <a:t>7–11</a:t>
+            </a:r>
+            <a:endParaRPr lang="en-US" sz="1000" dirty="0"/>
+          </a:p>
+        </p:txBody>
+      </p:sp>
+      <p:sp>
+        <p:nvSpPr>
+          <p:cNvPr id="20" name="Text 18"/>
+          <p:cNvSpPr txBox="1"/>
+          <p:nvPr/>
+        </p:nvSpPr>
+        <p:spPr>
+          <a:xfrm>
+            <a:off x="7476774" y="2148840"/>
+            <a:ext cx="1097280" cy="164592"/>
+          </a:xfrm>
+          <a:prstGeom prst="rect">
+            <a:avLst/>
+          </a:prstGeom>
+          <a:noFill/>
+          <a:ln/>
+        </p:spPr>
+        <p:txBody>
+          <a:bodyPr wrap="square" lIns="0" tIns="0" rIns="0" bIns="0" rtlCol="0" anchor="ctr"/>
+          <a:lstStyle/>
+          <a:p>
+            <a:pPr algn="ctr" indent="0" marL="0">
+              <a:buNone/>
+            </a:pPr>
+            <a:r>
+              <a:rPr lang="en-US" sz="800" dirty="0">
+                <a:solidFill>
+                  <a:srgbClr val="898781"/>
+                </a:solidFill>
+                <a:latin typeface="Arial" pitchFamily="34" charset="0"/>
+                <a:ea typeface="Arial" pitchFamily="34" charset="-122"/>
+                <a:cs typeface="Arial" pitchFamily="34" charset="-120"/>
+              </a:rPr>
+              <a:t>mediano</a:t>
+            </a:r>
+            <a:endParaRPr lang="en-US" sz="800" dirty="0"/>
+          </a:p>
+        </p:txBody>
+      </p:sp>
+      <p:sp>
+        <p:nvSpPr>
+          <p:cNvPr id="21" name="Shape 19"/>
+          <p:cNvSpPr/>
+          <p:nvPr/>
+        </p:nvSpPr>
+        <p:spPr>
+          <a:xfrm>
+            <a:off x="11149874" y="1837944"/>
+            <a:ext cx="256032" cy="256032"/>
+          </a:xfrm>
+          <a:prstGeom prst="ellipse">
+            <a:avLst/>
+          </a:prstGeom>
+          <a:solidFill>
+            <a:srgbClr val="1E3D5C"/>
+          </a:solidFill>
+          <a:ln w="19050">
+            <a:solidFill>
+              <a:srgbClr val="FFFFFF"/>
+            </a:solidFill>
+            <a:prstDash val="solid"/>
+          </a:ln>
+        </p:spPr>
+      </p:sp>
+      <p:sp>
+        <p:nvSpPr>
+          <p:cNvPr id="22" name="Text 20"/>
+          <p:cNvSpPr txBox="1"/>
+          <p:nvPr/>
+        </p:nvSpPr>
+        <p:spPr>
+          <a:xfrm>
+            <a:off x="10774970" y="1536192"/>
+            <a:ext cx="1005840" cy="182880"/>
+          </a:xfrm>
+          <a:prstGeom prst="rect">
+            <a:avLst/>
+          </a:prstGeom>
+          <a:noFill/>
+          <a:ln/>
+        </p:spPr>
+        <p:txBody>
+          <a:bodyPr wrap="square" lIns="0" tIns="0" rIns="0" bIns="0" rtlCol="0" anchor="ctr"/>
+          <a:lstStyle/>
+          <a:p>
+            <a:pPr algn="ctr" indent="0" marL="0">
+              <a:buNone/>
+            </a:pPr>
+            <a:r>
+              <a:rPr lang="en-US" sz="1000" b="1" dirty="0">
+                <a:solidFill>
+                  <a:srgbClr val="1E3D5C"/>
+                </a:solidFill>
+                <a:latin typeface="Arial" pitchFamily="34" charset="0"/>
+                <a:ea typeface="Arial" pitchFamily="34" charset="-122"/>
+                <a:cs typeface="Arial" pitchFamily="34" charset="-120"/>
+              </a:rPr>
+              <a:t>14–18</a:t>
+            </a:r>
+            <a:endParaRPr lang="en-US" sz="1000" dirty="0"/>
+          </a:p>
+        </p:txBody>
+      </p:sp>
+      <p:sp>
+        <p:nvSpPr>
+          <p:cNvPr id="23" name="Text 21"/>
+          <p:cNvSpPr txBox="1"/>
+          <p:nvPr/>
+        </p:nvSpPr>
+        <p:spPr>
+          <a:xfrm>
+            <a:off x="10729250" y="2148840"/>
+            <a:ext cx="1097280" cy="164592"/>
+          </a:xfrm>
+          <a:prstGeom prst="rect">
+            <a:avLst/>
+          </a:prstGeom>
+          <a:noFill/>
+          <a:ln/>
+        </p:spPr>
+        <p:txBody>
+          <a:bodyPr wrap="square" lIns="0" tIns="0" rIns="0" bIns="0" rtlCol="0" anchor="ctr"/>
+          <a:lstStyle/>
+          <a:p>
+            <a:pPr algn="ctr" indent="0" marL="0">
+              <a:buNone/>
+            </a:pPr>
+            <a:r>
+              <a:rPr lang="en-US" sz="800" dirty="0">
+                <a:solidFill>
+                  <a:srgbClr val="898781"/>
+                </a:solidFill>
+                <a:latin typeface="Arial" pitchFamily="34" charset="0"/>
+                <a:ea typeface="Arial" pitchFamily="34" charset="-122"/>
+                <a:cs typeface="Arial" pitchFamily="34" charset="-120"/>
+              </a:rPr>
+              <a:t>largo (2024)</a:t>
+            </a:r>
+            <a:endParaRPr lang="en-US" sz="800" dirty="0"/>
+          </a:p>
+        </p:txBody>
+      </p:sp>
+      <p:sp>
+        <p:nvSpPr>
+          <p:cNvPr id="24" name="Shape 22"/>
+          <p:cNvSpPr/>
+          <p:nvPr/>
+        </p:nvSpPr>
+        <p:spPr>
+          <a:xfrm>
+            <a:off x="5008626" y="2926080"/>
+            <a:ext cx="6649974" cy="274320"/>
+          </a:xfrm>
+          <a:prstGeom prst="roundRect">
+            <a:avLst>
+              <a:gd name="adj" fmla="val 26667"/>
+            </a:avLst>
+          </a:prstGeom>
+          <a:solidFill>
+            <a:srgbClr val="D2EBDD"/>
+          </a:solidFill>
+          <a:ln w="12700">
+            <a:solidFill>
+              <a:srgbClr val="1BAF7A"/>
+            </a:solidFill>
+            <a:prstDash val="solid"/>
+          </a:ln>
+        </p:spPr>
+      </p:sp>
+      <p:sp>
+        <p:nvSpPr>
+          <p:cNvPr id="25" name="Text 23"/>
+          <p:cNvSpPr txBox="1"/>
+          <p:nvPr/>
+        </p:nvSpPr>
+        <p:spPr>
+          <a:xfrm>
+            <a:off x="457200" y="2788920"/>
+            <a:ext cx="2103120" cy="182880"/>
+          </a:xfrm>
+          <a:prstGeom prst="rect">
+            <a:avLst/>
+          </a:prstGeom>
+          <a:noFill/>
+          <a:ln/>
+        </p:spPr>
+        <p:txBody>
+          <a:bodyPr wrap="square" lIns="0" tIns="0" rIns="0" bIns="0" rtlCol="0" anchor="ctr"/>
+          <a:lstStyle/>
+          <a:p>
+            <a:pPr algn="l" indent="0" marL="0">
+              <a:buNone/>
+            </a:pPr>
+            <a:r>
+              <a:rPr lang="en-US" sz="950" b="1" dirty="0">
+                <a:solidFill>
+                  <a:srgbClr val="0B0B0B"/>
+                </a:solidFill>
+                <a:latin typeface="Arial" pitchFamily="34" charset="0"/>
+                <a:ea typeface="Arial" pitchFamily="34" charset="-122"/>
+                <a:cs typeface="Arial" pitchFamily="34" charset="-120"/>
+              </a:rPr>
+              <a:t>AFFECTED = 0</a:t>
+            </a:r>
+            <a:endParaRPr lang="en-US" sz="950" dirty="0"/>
+          </a:p>
+        </p:txBody>
+      </p:sp>
+      <p:sp>
+        <p:nvSpPr>
+          <p:cNvPr id="26" name="Text 24"/>
+          <p:cNvSpPr txBox="1"/>
+          <p:nvPr/>
+        </p:nvSpPr>
+        <p:spPr>
+          <a:xfrm>
+            <a:off x="457200" y="2980944"/>
+            <a:ext cx="2103120" cy="384048"/>
+          </a:xfrm>
+          <a:prstGeom prst="rect">
+            <a:avLst/>
+          </a:prstGeom>
+          <a:noFill/>
+          <a:ln/>
+        </p:spPr>
+        <p:txBody>
+          <a:bodyPr wrap="square" lIns="0" tIns="0" rIns="0" bIns="0" rtlCol="0" anchor="ctr"/>
+          <a:lstStyle/>
+          <a:p>
+            <a:pPr algn="l" indent="0" marL="0">
+              <a:buNone/>
+            </a:pPr>
+            <a:r>
+              <a:rPr lang="en-US" sz="800" dirty="0">
+                <a:solidFill>
+                  <a:srgbClr val="52514E"/>
+                </a:solidFill>
+                <a:latin typeface="Arial" pitchFamily="34" charset="0"/>
+                <a:ea typeface="Arial" pitchFamily="34" charset="-122"/>
+                <a:cs typeface="Arial" pitchFamily="34" charset="-120"/>
+              </a:rPr>
+              <a:t>Nacidos 2011 — refresco 2012</a:t>
+            </a:r>
+            <a:endParaRPr lang="en-US" sz="800" dirty="0"/>
+          </a:p>
+        </p:txBody>
+      </p:sp>
+      <p:sp>
+        <p:nvSpPr>
+          <p:cNvPr id="27" name="Shape 25"/>
+          <p:cNvSpPr/>
+          <p:nvPr/>
+        </p:nvSpPr>
+        <p:spPr>
+          <a:xfrm>
+            <a:off x="7897398" y="2935224"/>
+            <a:ext cx="256032" cy="256032"/>
+          </a:xfrm>
+          <a:prstGeom prst="ellipse">
+            <a:avLst/>
+          </a:prstGeom>
+          <a:solidFill>
+            <a:srgbClr val="1BAF7A"/>
+          </a:solidFill>
+          <a:ln w="19050">
+            <a:solidFill>
+              <a:srgbClr val="FFFFFF"/>
+            </a:solidFill>
+            <a:prstDash val="solid"/>
+          </a:ln>
+        </p:spPr>
+      </p:sp>
+      <p:sp>
+        <p:nvSpPr>
+          <p:cNvPr id="28" name="Text 26"/>
+          <p:cNvSpPr txBox="1"/>
+          <p:nvPr/>
+        </p:nvSpPr>
+        <p:spPr>
+          <a:xfrm>
+            <a:off x="7522494" y="2633472"/>
+            <a:ext cx="1005840" cy="182880"/>
+          </a:xfrm>
+          <a:prstGeom prst="rect">
+            <a:avLst/>
+          </a:prstGeom>
+          <a:noFill/>
+          <a:ln/>
+        </p:spPr>
+        <p:txBody>
+          <a:bodyPr wrap="square" lIns="0" tIns="0" rIns="0" bIns="0" rtlCol="0" anchor="ctr"/>
+          <a:lstStyle/>
+          <a:p>
+            <a:pPr algn="ctr" indent="0" marL="0">
+              <a:buNone/>
+            </a:pPr>
+            <a:r>
+              <a:rPr lang="en-US" sz="1000" b="1" dirty="0">
+                <a:solidFill>
+                  <a:srgbClr val="0E7A54"/>
+                </a:solidFill>
+                <a:latin typeface="Arial" pitchFamily="34" charset="0"/>
+                <a:ea typeface="Arial" pitchFamily="34" charset="-122"/>
+                <a:cs typeface="Arial" pitchFamily="34" charset="-120"/>
+              </a:rPr>
+              <a:t>5–6</a:t>
+            </a:r>
+            <a:endParaRPr lang="en-US" sz="1000" dirty="0"/>
+          </a:p>
+        </p:txBody>
+      </p:sp>
+      <p:sp>
+        <p:nvSpPr>
+          <p:cNvPr id="29" name="Text 27"/>
+          <p:cNvSpPr txBox="1"/>
+          <p:nvPr/>
+        </p:nvSpPr>
+        <p:spPr>
+          <a:xfrm>
+            <a:off x="7476774" y="3246120"/>
+            <a:ext cx="1097280" cy="164592"/>
+          </a:xfrm>
+          <a:prstGeom prst="rect">
+            <a:avLst/>
+          </a:prstGeom>
+          <a:noFill/>
+          <a:ln/>
+        </p:spPr>
+        <p:txBody>
+          <a:bodyPr wrap="square" lIns="0" tIns="0" rIns="0" bIns="0" rtlCol="0" anchor="ctr"/>
+          <a:lstStyle/>
+          <a:p>
+            <a:pPr algn="ctr" indent="0" marL="0">
+              <a:buNone/>
+            </a:pPr>
+            <a:r>
+              <a:rPr lang="en-US" sz="800" dirty="0">
+                <a:solidFill>
+                  <a:srgbClr val="898781"/>
+                </a:solidFill>
+                <a:latin typeface="Arial" pitchFamily="34" charset="0"/>
+                <a:ea typeface="Arial" pitchFamily="34" charset="-122"/>
+                <a:cs typeface="Arial" pitchFamily="34" charset="-120"/>
+              </a:rPr>
+              <a:t>control</a:t>
+            </a:r>
+            <a:endParaRPr lang="en-US" sz="800" dirty="0"/>
+          </a:p>
+        </p:txBody>
+      </p:sp>
+      <p:sp>
+        <p:nvSpPr>
+          <p:cNvPr id="30" name="Shape 28"/>
+          <p:cNvSpPr/>
+          <p:nvPr/>
+        </p:nvSpPr>
+        <p:spPr>
+          <a:xfrm>
+            <a:off x="5479999" y="3749040"/>
+            <a:ext cx="6178601" cy="274320"/>
+          </a:xfrm>
+          <a:prstGeom prst="roundRect">
+            <a:avLst>
+              <a:gd name="adj" fmla="val 26667"/>
+            </a:avLst>
+          </a:prstGeom>
+          <a:solidFill>
+            <a:srgbClr val="D2EBDD"/>
+          </a:solidFill>
+          <a:ln w="12700">
+            <a:solidFill>
+              <a:srgbClr val="1BAF7A"/>
+            </a:solidFill>
+            <a:prstDash val="solid"/>
+          </a:ln>
+        </p:spPr>
+      </p:sp>
+      <p:sp>
+        <p:nvSpPr>
+          <p:cNvPr id="31" name="Text 29"/>
+          <p:cNvSpPr txBox="1"/>
+          <p:nvPr/>
+        </p:nvSpPr>
+        <p:spPr>
+          <a:xfrm>
+            <a:off x="457200" y="3611880"/>
+            <a:ext cx="2103120" cy="182880"/>
+          </a:xfrm>
+          <a:prstGeom prst="rect">
+            <a:avLst/>
+          </a:prstGeom>
+          <a:noFill/>
+          <a:ln/>
+        </p:spPr>
+        <p:txBody>
+          <a:bodyPr wrap="square" lIns="0" tIns="0" rIns="0" bIns="0" rtlCol="0" anchor="ctr"/>
+          <a:lstStyle/>
+          <a:p>
+            <a:pPr algn="l" indent="0" marL="0">
+              <a:buNone/>
+            </a:pPr>
+            <a:r>
+              <a:rPr lang="en-US" sz="950" b="1" dirty="0">
+                <a:solidFill>
+                  <a:srgbClr val="0B0B0B"/>
+                </a:solidFill>
+                <a:latin typeface="Arial" pitchFamily="34" charset="0"/>
+                <a:ea typeface="Arial" pitchFamily="34" charset="-122"/>
+                <a:cs typeface="Arial" pitchFamily="34" charset="-120"/>
+              </a:rPr>
+              <a:t>AFFECTED = 0</a:t>
+            </a:r>
+            <a:endParaRPr lang="en-US" sz="950" dirty="0"/>
+          </a:p>
+        </p:txBody>
+      </p:sp>
+      <p:sp>
+        <p:nvSpPr>
+          <p:cNvPr id="32" name="Text 30"/>
+          <p:cNvSpPr txBox="1"/>
+          <p:nvPr/>
+        </p:nvSpPr>
+        <p:spPr>
+          <a:xfrm>
+            <a:off x="457200" y="3803904"/>
+            <a:ext cx="2103120" cy="384048"/>
+          </a:xfrm>
+          <a:prstGeom prst="rect">
+            <a:avLst/>
+          </a:prstGeom>
+          <a:noFill/>
+          <a:ln/>
+        </p:spPr>
+        <p:txBody>
+          <a:bodyPr wrap="square" lIns="0" tIns="0" rIns="0" bIns="0" rtlCol="0" anchor="ctr"/>
+          <a:lstStyle/>
+          <a:p>
+            <a:pPr algn="l" indent="0" marL="0">
+              <a:buNone/>
+            </a:pPr>
+            <a:r>
+              <a:rPr lang="en-US" sz="800" dirty="0">
+                <a:solidFill>
+                  <a:srgbClr val="52514E"/>
+                </a:solidFill>
+                <a:latin typeface="Arial" pitchFamily="34" charset="0"/>
+                <a:ea typeface="Arial" pitchFamily="34" charset="-122"/>
+                <a:cs typeface="Arial" pitchFamily="34" charset="-120"/>
+              </a:rPr>
+              <a:t>Nacidos 2012–2015 — refresco 2017</a:t>
+            </a:r>
+            <a:endParaRPr lang="en-US" sz="800" dirty="0"/>
+          </a:p>
+        </p:txBody>
+      </p:sp>
+      <p:sp>
+        <p:nvSpPr>
+          <p:cNvPr id="33" name="Shape 31"/>
+          <p:cNvSpPr/>
+          <p:nvPr/>
+        </p:nvSpPr>
+        <p:spPr>
+          <a:xfrm>
+            <a:off x="7897398" y="3758184"/>
+            <a:ext cx="256032" cy="256032"/>
+          </a:xfrm>
+          <a:prstGeom prst="ellipse">
+            <a:avLst/>
+          </a:prstGeom>
+          <a:solidFill>
+            <a:srgbClr val="1BAF7A"/>
+          </a:solidFill>
+          <a:ln w="19050">
+            <a:solidFill>
+              <a:srgbClr val="FFFFFF"/>
+            </a:solidFill>
+            <a:prstDash val="solid"/>
+          </a:ln>
+        </p:spPr>
+      </p:sp>
+      <p:sp>
+        <p:nvSpPr>
+          <p:cNvPr id="34" name="Text 32"/>
+          <p:cNvSpPr txBox="1"/>
+          <p:nvPr/>
+        </p:nvSpPr>
+        <p:spPr>
+          <a:xfrm>
+            <a:off x="7522494" y="3456432"/>
+            <a:ext cx="1005840" cy="182880"/>
+          </a:xfrm>
+          <a:prstGeom prst="rect">
+            <a:avLst/>
+          </a:prstGeom>
+          <a:noFill/>
+          <a:ln/>
+        </p:spPr>
+        <p:txBody>
+          <a:bodyPr wrap="square" lIns="0" tIns="0" rIns="0" bIns="0" rtlCol="0" anchor="ctr"/>
+          <a:lstStyle/>
+          <a:p>
+            <a:pPr algn="ctr" indent="0" marL="0">
+              <a:buNone/>
+            </a:pPr>
+            <a:r>
+              <a:rPr lang="en-US" sz="1000" b="1" dirty="0">
+                <a:solidFill>
+                  <a:srgbClr val="0E7A54"/>
+                </a:solidFill>
+                <a:latin typeface="Arial" pitchFamily="34" charset="0"/>
+                <a:ea typeface="Arial" pitchFamily="34" charset="-122"/>
+                <a:cs typeface="Arial" pitchFamily="34" charset="-120"/>
+              </a:rPr>
+              <a:t>2–5</a:t>
+            </a:r>
+            <a:endParaRPr lang="en-US" sz="1000" dirty="0"/>
+          </a:p>
+        </p:txBody>
+      </p:sp>
+      <p:sp>
+        <p:nvSpPr>
+          <p:cNvPr id="35" name="Text 33"/>
+          <p:cNvSpPr txBox="1"/>
+          <p:nvPr/>
+        </p:nvSpPr>
+        <p:spPr>
+          <a:xfrm>
+            <a:off x="7476774" y="4069080"/>
+            <a:ext cx="1097280" cy="164592"/>
+          </a:xfrm>
+          <a:prstGeom prst="rect">
+            <a:avLst/>
+          </a:prstGeom>
+          <a:noFill/>
+          <a:ln/>
+        </p:spPr>
+        <p:txBody>
+          <a:bodyPr wrap="square" lIns="0" tIns="0" rIns="0" bIns="0" rtlCol="0" anchor="ctr"/>
+          <a:lstStyle/>
+          <a:p>
+            <a:pPr algn="ctr" indent="0" marL="0">
+              <a:buNone/>
+            </a:pPr>
+            <a:r>
+              <a:rPr lang="en-US" sz="800" dirty="0">
+                <a:solidFill>
+                  <a:srgbClr val="898781"/>
+                </a:solidFill>
+                <a:latin typeface="Arial" pitchFamily="34" charset="0"/>
+                <a:ea typeface="Arial" pitchFamily="34" charset="-122"/>
+                <a:cs typeface="Arial" pitchFamily="34" charset="-120"/>
+              </a:rPr>
+              <a:t>control</a:t>
+            </a:r>
+            <a:endParaRPr lang="en-US" sz="800" dirty="0"/>
+          </a:p>
+        </p:txBody>
+      </p:sp>
+      <p:sp>
+        <p:nvSpPr>
+          <p:cNvPr id="36" name="Text 34"/>
+          <p:cNvSpPr txBox="1"/>
+          <p:nvPr/>
+        </p:nvSpPr>
+        <p:spPr>
+          <a:xfrm>
+            <a:off x="11095010" y="2889504"/>
+            <a:ext cx="365760" cy="329184"/>
+          </a:xfrm>
+          <a:prstGeom prst="rect">
+            <a:avLst/>
+          </a:prstGeom>
+          <a:noFill/>
+          <a:ln/>
+        </p:spPr>
+        <p:txBody>
+          <a:bodyPr wrap="square" lIns="0" tIns="0" rIns="0" bIns="0" rtlCol="0" anchor="ctr"/>
+          <a:lstStyle/>
+          <a:p>
+            <a:pPr algn="ctr" indent="0" marL="0">
+              <a:buNone/>
+            </a:pPr>
+            <a:r>
+              <a:rPr lang="en-US" sz="1600" b="1" dirty="0">
+                <a:solidFill>
+                  <a:srgbClr val="C0392B"/>
+                </a:solidFill>
+                <a:latin typeface="Arial" pitchFamily="34" charset="0"/>
+                <a:ea typeface="Arial" pitchFamily="34" charset="-122"/>
+                <a:cs typeface="Arial" pitchFamily="34" charset="-120"/>
+              </a:rPr>
+              <a:t>✕</a:t>
+            </a:r>
+            <a:endParaRPr lang="en-US" sz="1600" dirty="0"/>
+          </a:p>
+        </p:txBody>
+      </p:sp>
+      <p:sp>
+        <p:nvSpPr>
+          <p:cNvPr id="37" name="Text 35"/>
+          <p:cNvSpPr txBox="1"/>
+          <p:nvPr/>
+        </p:nvSpPr>
+        <p:spPr>
+          <a:xfrm>
+            <a:off x="11095010" y="3712464"/>
+            <a:ext cx="365760" cy="329184"/>
+          </a:xfrm>
+          <a:prstGeom prst="rect">
+            <a:avLst/>
+          </a:prstGeom>
+          <a:noFill/>
+          <a:ln/>
+        </p:spPr>
+        <p:txBody>
+          <a:bodyPr wrap="square" lIns="0" tIns="0" rIns="0" bIns="0" rtlCol="0" anchor="ctr"/>
+          <a:lstStyle/>
+          <a:p>
+            <a:pPr algn="ctr" indent="0" marL="0">
+              <a:buNone/>
+            </a:pPr>
+            <a:r>
+              <a:rPr lang="en-US" sz="1600" b="1" dirty="0">
+                <a:solidFill>
+                  <a:srgbClr val="C0392B"/>
+                </a:solidFill>
+                <a:latin typeface="Arial" pitchFamily="34" charset="0"/>
+                <a:ea typeface="Arial" pitchFamily="34" charset="-122"/>
+                <a:cs typeface="Arial" pitchFamily="34" charset="-120"/>
+              </a:rPr>
+              <a:t>✕</a:t>
+            </a:r>
+            <a:endParaRPr lang="en-US" sz="1600" dirty="0"/>
+          </a:p>
+        </p:txBody>
+      </p:sp>
+      <p:sp>
+        <p:nvSpPr>
+          <p:cNvPr id="38" name="Text 36"/>
+          <p:cNvSpPr txBox="1"/>
+          <p:nvPr/>
+        </p:nvSpPr>
+        <p:spPr>
+          <a:xfrm>
+            <a:off x="10500650" y="4142232"/>
+            <a:ext cx="1554480" cy="182880"/>
+          </a:xfrm>
+          <a:prstGeom prst="rect">
+            <a:avLst/>
+          </a:prstGeom>
+          <a:noFill/>
+          <a:ln/>
+        </p:spPr>
+        <p:txBody>
+          <a:bodyPr wrap="square" lIns="0" tIns="0" rIns="0" bIns="0" rtlCol="0" anchor="ctr"/>
+          <a:lstStyle/>
+          <a:p>
+            <a:pPr algn="ctr" indent="0" marL="0">
+              <a:buNone/>
+            </a:pPr>
+            <a:r>
+              <a:rPr lang="en-US" sz="800" b="1" dirty="0">
+                <a:solidFill>
+                  <a:srgbClr val="C0392B"/>
+                </a:solidFill>
+                <a:latin typeface="Arial" pitchFamily="34" charset="0"/>
+                <a:ea typeface="Arial" pitchFamily="34" charset="-122"/>
+                <a:cs typeface="Arial" pitchFamily="34" charset="-120"/>
+              </a:rPr>
+              <a:t>no re-entrevistados</a:t>
+            </a:r>
+            <a:endParaRPr lang="en-US" sz="800" dirty="0"/>
+          </a:p>
+        </p:txBody>
+      </p:sp>
+      <p:sp>
+        <p:nvSpPr>
+          <p:cNvPr id="39" name="Shape 37"/>
+          <p:cNvSpPr/>
+          <p:nvPr/>
+        </p:nvSpPr>
+        <p:spPr>
+          <a:xfrm>
+            <a:off x="457200" y="4617720"/>
+            <a:ext cx="3630168" cy="1645920"/>
+          </a:xfrm>
+          <a:prstGeom prst="roundRect">
+            <a:avLst>
+              <a:gd name="adj" fmla="val 3889"/>
+            </a:avLst>
+          </a:prstGeom>
+          <a:solidFill>
+            <a:srgbClr val="EDF3FC"/>
+          </a:solidFill>
+          <a:ln/>
+        </p:spPr>
+      </p:sp>
+      <p:sp>
+        <p:nvSpPr>
+          <p:cNvPr id="40" name="Text 38"/>
+          <p:cNvSpPr txBox="1"/>
+          <p:nvPr/>
+        </p:nvSpPr>
+        <p:spPr>
+          <a:xfrm>
+            <a:off x="603504" y="4727448"/>
+            <a:ext cx="3337560" cy="219456"/>
+          </a:xfrm>
+          <a:prstGeom prst="rect">
+            <a:avLst/>
+          </a:prstGeom>
+          <a:noFill/>
+          <a:ln/>
+        </p:spPr>
+        <p:txBody>
+          <a:bodyPr wrap="square" lIns="0" tIns="0" rIns="0" bIns="0" rtlCol="0" anchor="ctr"/>
+          <a:lstStyle/>
+          <a:p>
+            <a:pPr algn="l" indent="0" marL="0">
+              <a:buNone/>
+            </a:pPr>
+            <a:r>
+              <a:rPr lang="en-US" sz="1050" b="1" dirty="0">
+                <a:solidFill>
+                  <a:srgbClr val="1E3D5C"/>
+                </a:solidFill>
+                <a:latin typeface="Arial" pitchFamily="34" charset="0"/>
+                <a:ea typeface="Arial" pitchFamily="34" charset="-122"/>
+                <a:cs typeface="Arial" pitchFamily="34" charset="-120"/>
+              </a:rPr>
+              <a:t>CORTO PLAZO · 2 años</a:t>
+            </a:r>
+            <a:endParaRPr lang="en-US" sz="1050" dirty="0"/>
+          </a:p>
+        </p:txBody>
+      </p:sp>
+      <p:sp>
+        <p:nvSpPr>
+          <p:cNvPr id="41" name="Text 39"/>
+          <p:cNvSpPr txBox="1"/>
+          <p:nvPr/>
+        </p:nvSpPr>
+        <p:spPr>
+          <a:xfrm>
+            <a:off x="603504" y="4983480"/>
+            <a:ext cx="3337560" cy="1188720"/>
+          </a:xfrm>
+          <a:prstGeom prst="rect">
+            <a:avLst/>
+          </a:prstGeom>
+          <a:noFill/>
+          <a:ln/>
+        </p:spPr>
+        <p:txBody>
+          <a:bodyPr wrap="square" lIns="0" tIns="0" rIns="0" bIns="0" rtlCol="0" anchor="ctr"/>
+          <a:lstStyle/>
+          <a:p>
+            <a:pPr algn="l" indent="0" marL="0">
+              <a:lnSpc>
+                <a:spcPct val="105000"/>
+              </a:lnSpc>
+              <a:buNone/>
+            </a:pPr>
+            <a:r>
+              <a:rPr lang="en-US" sz="930" dirty="0">
+                <a:solidFill>
+                  <a:srgbClr val="52514E"/>
+                </a:solidFill>
+                <a:latin typeface="Arial" pitchFamily="34" charset="0"/>
+                <a:ea typeface="Arial" pitchFamily="34" charset="-122"/>
+                <a:cs typeface="Arial" pitchFamily="34" charset="-120"/>
+              </a:rPr>
+              <a:t>Tratados con 2–6 años (ola 2012) vs. controles con 2–6 años (ola 2017): misma edad, distinta ola — la diferencia de ola la absorbe ηw.</a:t>
+            </a:r>
+            <a:endParaRPr lang="en-US" sz="930" dirty="0"/>
+          </a:p>
+        </p:txBody>
+      </p:sp>
+      <p:sp>
+        <p:nvSpPr>
+          <p:cNvPr id="42" name="Shape 40"/>
+          <p:cNvSpPr/>
+          <p:nvPr/>
+        </p:nvSpPr>
+        <p:spPr>
+          <a:xfrm>
+            <a:off x="4270248" y="4617720"/>
+            <a:ext cx="3630168" cy="1645920"/>
+          </a:xfrm>
+          <a:prstGeom prst="roundRect">
+            <a:avLst>
+              <a:gd name="adj" fmla="val 3889"/>
+            </a:avLst>
+          </a:prstGeom>
+          <a:solidFill>
+            <a:srgbClr val="EDF3FC"/>
+          </a:solidFill>
+          <a:ln/>
+        </p:spPr>
+      </p:sp>
+      <p:sp>
+        <p:nvSpPr>
+          <p:cNvPr id="43" name="Text 41"/>
+          <p:cNvSpPr txBox="1"/>
+          <p:nvPr/>
+        </p:nvSpPr>
+        <p:spPr>
+          <a:xfrm>
+            <a:off x="4416552" y="4727448"/>
+            <a:ext cx="3337560" cy="219456"/>
+          </a:xfrm>
+          <a:prstGeom prst="rect">
+            <a:avLst/>
+          </a:prstGeom>
+          <a:noFill/>
+          <a:ln/>
+        </p:spPr>
+        <p:txBody>
+          <a:bodyPr wrap="square" lIns="0" tIns="0" rIns="0" bIns="0" rtlCol="0" anchor="ctr"/>
+          <a:lstStyle/>
+          <a:p>
+            <a:pPr algn="l" indent="0" marL="0">
+              <a:buNone/>
+            </a:pPr>
+            <a:r>
+              <a:rPr lang="en-US" sz="1050" b="1" dirty="0">
+                <a:solidFill>
+                  <a:srgbClr val="1E3D5C"/>
+                </a:solidFill>
+                <a:latin typeface="Arial" pitchFamily="34" charset="0"/>
+                <a:ea typeface="Arial" pitchFamily="34" charset="-122"/>
+                <a:cs typeface="Arial" pitchFamily="34" charset="-120"/>
+              </a:rPr>
+              <a:t>MEDIANO PLAZO · 7 años</a:t>
+            </a:r>
+            <a:endParaRPr lang="en-US" sz="1050" dirty="0"/>
+          </a:p>
+        </p:txBody>
+      </p:sp>
+      <p:sp>
+        <p:nvSpPr>
+          <p:cNvPr id="44" name="Text 42"/>
+          <p:cNvSpPr txBox="1"/>
+          <p:nvPr/>
+        </p:nvSpPr>
+        <p:spPr>
+          <a:xfrm>
+            <a:off x="4416552" y="4983480"/>
+            <a:ext cx="3337560" cy="1188720"/>
+          </a:xfrm>
+          <a:prstGeom prst="rect">
+            <a:avLst/>
+          </a:prstGeom>
+          <a:noFill/>
+          <a:ln/>
+        </p:spPr>
+        <p:txBody>
+          <a:bodyPr wrap="square" lIns="0" tIns="0" rIns="0" bIns="0" rtlCol="0" anchor="ctr"/>
+          <a:lstStyle/>
+          <a:p>
+            <a:pPr algn="l" indent="0" marL="0">
+              <a:lnSpc>
+                <a:spcPct val="105000"/>
+              </a:lnSpc>
+              <a:buNone/>
+            </a:pPr>
+            <a:r>
+              <a:rPr lang="en-US" sz="930" dirty="0">
+                <a:solidFill>
+                  <a:srgbClr val="52514E"/>
+                </a:solidFill>
+                <a:latin typeface="Arial" pitchFamily="34" charset="0"/>
+                <a:ea typeface="Arial" pitchFamily="34" charset="-122"/>
+                <a:cs typeface="Arial" pitchFamily="34" charset="-120"/>
+              </a:rPr>
+              <a:t>Tratados 7–11 vs. controles 2–6, todos en la ola 2017: misma ola, distinta edad — tests normados por edad (+ z por tramo).</a:t>
+            </a:r>
+            <a:endParaRPr lang="en-US" sz="930" dirty="0"/>
+          </a:p>
+        </p:txBody>
+      </p:sp>
+      <p:sp>
+        <p:nvSpPr>
+          <p:cNvPr id="45" name="Shape 43"/>
+          <p:cNvSpPr/>
+          <p:nvPr/>
+        </p:nvSpPr>
+        <p:spPr>
+          <a:xfrm>
+            <a:off x="8083296" y="4617720"/>
+            <a:ext cx="3630168" cy="1645920"/>
+          </a:xfrm>
+          <a:prstGeom prst="roundRect">
+            <a:avLst>
+              <a:gd name="adj" fmla="val 3889"/>
+            </a:avLst>
+          </a:prstGeom>
+          <a:solidFill>
+            <a:srgbClr val="FDE8DC"/>
+          </a:solidFill>
+          <a:ln/>
+        </p:spPr>
+      </p:sp>
+      <p:sp>
+        <p:nvSpPr>
+          <p:cNvPr id="46" name="Text 44"/>
+          <p:cNvSpPr txBox="1"/>
+          <p:nvPr/>
+        </p:nvSpPr>
+        <p:spPr>
+          <a:xfrm>
+            <a:off x="8229600" y="4727448"/>
+            <a:ext cx="3337560" cy="219456"/>
+          </a:xfrm>
+          <a:prstGeom prst="rect">
+            <a:avLst/>
+          </a:prstGeom>
+          <a:noFill/>
+          <a:ln/>
+        </p:spPr>
+        <p:txBody>
+          <a:bodyPr wrap="square" lIns="0" tIns="0" rIns="0" bIns="0" rtlCol="0" anchor="ctr"/>
+          <a:lstStyle/>
+          <a:p>
+            <a:pPr algn="l" indent="0" marL="0">
+              <a:buNone/>
+            </a:pPr>
+            <a:r>
+              <a:rPr lang="en-US" sz="1050" b="1" dirty="0">
+                <a:solidFill>
+                  <a:srgbClr val="1E3D5C"/>
+                </a:solidFill>
+                <a:latin typeface="Arial" pitchFamily="34" charset="0"/>
+                <a:ea typeface="Arial" pitchFamily="34" charset="-122"/>
+                <a:cs typeface="Arial" pitchFamily="34" charset="-120"/>
+              </a:rPr>
+              <a:t>LARGO PLAZO · 14 años (nuestro)</a:t>
+            </a:r>
+            <a:endParaRPr lang="en-US" sz="1050" dirty="0"/>
+          </a:p>
+        </p:txBody>
+      </p:sp>
+      <p:sp>
+        <p:nvSpPr>
+          <p:cNvPr id="47" name="Text 45"/>
+          <p:cNvSpPr txBox="1"/>
+          <p:nvPr/>
+        </p:nvSpPr>
+        <p:spPr>
+          <a:xfrm>
+            <a:off x="8229600" y="4983480"/>
+            <a:ext cx="3337560" cy="1188720"/>
+          </a:xfrm>
+          <a:prstGeom prst="rect">
+            <a:avLst/>
+          </a:prstGeom>
+          <a:noFill/>
+          <a:ln/>
+        </p:spPr>
+        <p:txBody>
+          <a:bodyPr wrap="square" lIns="0" tIns="0" rIns="0" bIns="0" rtlCol="0" anchor="ctr"/>
+          <a:lstStyle/>
+          <a:p>
+            <a:pPr algn="l" indent="0" marL="0">
+              <a:lnSpc>
+                <a:spcPct val="105000"/>
+              </a:lnSpc>
+              <a:buNone/>
+            </a:pPr>
+            <a:r>
+              <a:rPr lang="en-US" sz="930" dirty="0">
+                <a:solidFill>
+                  <a:srgbClr val="52514E"/>
+                </a:solidFill>
+                <a:latin typeface="Arial" pitchFamily="34" charset="0"/>
+                <a:ea typeface="Arial" pitchFamily="34" charset="-122"/>
+                <a:cs typeface="Arial" pitchFamily="34" charset="-120"/>
+              </a:rPr>
+              <a:t>Tratados 14–18 en la ola 2024. El control NO fue re-entrevistado: se importa de la ola 2017 (CBCL2, TVIP) — y para PHQ/GAD no existe en ninguna ola.</a:t>
+            </a:r>
+            <a:endParaRPr lang="en-US" sz="930" dirty="0"/>
+          </a:p>
+        </p:txBody>
+      </p:sp>
+      <p:sp>
+        <p:nvSpPr>
+          <p:cNvPr id="48" name="Text 46"/>
+          <p:cNvSpPr txBox="1"/>
+          <p:nvPr/>
+        </p:nvSpPr>
+        <p:spPr>
+          <a:xfrm>
+            <a:off x="457200" y="6528816"/>
+            <a:ext cx="11274552" cy="219456"/>
+          </a:xfrm>
+          <a:prstGeom prst="rect">
+            <a:avLst/>
+          </a:prstGeom>
+          <a:noFill/>
+          <a:ln/>
+        </p:spPr>
+        <p:txBody>
+          <a:bodyPr wrap="square" lIns="0" tIns="0" rIns="0" bIns="0" rtlCol="0" anchor="ctr"/>
+          <a:lstStyle/>
+          <a:p>
+            <a:pPr algn="l" indent="0" marL="0">
+              <a:buNone/>
+            </a:pPr>
+            <a:r>
+              <a:rPr lang="en-US" sz="800" dirty="0">
+                <a:solidFill>
+                  <a:srgbClr val="898781"/>
+                </a:solidFill>
+                <a:latin typeface="Arial" pitchFamily="34" charset="0"/>
+                <a:ea typeface="Arial" pitchFamily="34" charset="-122"/>
+                <a:cs typeface="Arial" pitchFamily="34" charset="-120"/>
+              </a:rPr>
+              <a:t>Estructura muestral según ap. T3–T4 de Gillmore (EER 2026) y microdato ELPI. ηw = efecto fijo de ola de la ec. (1).</a:t>
+            </a:r>
+            <a:endParaRPr lang="en-US" sz="800" dirty="0"/>
+          </a:p>
+        </p:txBody>
+      </p:sp>
+    </p:spTree>
+  </p:cSld>
+  <p:clrMapOvr>
+    <a:masterClrMapping/>
+  </p:clrMapOvr>
+</p:sld>
+</file>
+
 <file path=ppt/theme/theme1.xml><?xml version="1.0" encoding="utf-8"?>
 <a:theme xmlns:a="http://schemas.openxmlformats.org/drawingml/2006/main" name="Office Theme">
   <a:themeElements>

</xml_diff>

<commit_message>
Diapo 6: marca de entrada a la ELPI y regla de lectura de las barras
Co-Authored-By: Claude Fable 5 <noreply@anthropic.com>
Claude-Session: https://claude.ai/code/session_01UqKvCdoWhpNY2WRQ7PFfps
</commit_message>
<xml_diff>
--- a/docs/presentacion_elpi_gillmore.pptx
+++ b/docs/presentacion_elpi_gillmore.pptx
@@ -9621,6 +9621,109 @@
         </p:nvSpPr>
         <p:spPr>
           <a:xfrm>
+            <a:off x="5586252" y="2980944"/>
+            <a:ext cx="164592" cy="164592"/>
+          </a:xfrm>
+          <a:prstGeom prst="ellipse">
+            <a:avLst/>
+          </a:prstGeom>
+          <a:solidFill>
+            <a:srgbClr val="FFFFFF"/>
+          </a:solidFill>
+          <a:ln w="22225">
+            <a:solidFill>
+              <a:srgbClr val="0E7A54"/>
+            </a:solidFill>
+            <a:prstDash val="solid"/>
+          </a:ln>
+        </p:spPr>
+      </p:sp>
+      <p:sp>
+        <p:nvSpPr>
+          <p:cNvPr id="40" name="Text 38"/>
+          <p:cNvSpPr txBox="1"/>
+          <p:nvPr/>
+        </p:nvSpPr>
+        <p:spPr>
+          <a:xfrm>
+            <a:off x="4799868" y="3218688"/>
+            <a:ext cx="1737360" cy="164592"/>
+          </a:xfrm>
+          <a:prstGeom prst="rect">
+            <a:avLst/>
+          </a:prstGeom>
+          <a:noFill/>
+          <a:ln/>
+        </p:spPr>
+        <p:txBody>
+          <a:bodyPr wrap="square" lIns="0" tIns="0" rIns="0" bIns="0" rtlCol="0" anchor="ctr"/>
+          <a:lstStyle/>
+          <a:p>
+            <a:pPr algn="ctr" indent="0" marL="0">
+              <a:buNone/>
+            </a:pPr>
+            <a:r>
+              <a:rPr lang="en-US" sz="750" i="1" dirty="0">
+                <a:solidFill>
+                  <a:srgbClr val="0E7A54"/>
+                </a:solidFill>
+                <a:latin typeface="Arial" pitchFamily="34" charset="0"/>
+                <a:ea typeface="Arial" pitchFamily="34" charset="-122"/>
+                <a:cs typeface="Arial" pitchFamily="34" charset="-120"/>
+              </a:rPr>
+              <a:t>entra (refresco 2012, con 0–1 año)</a:t>
+            </a:r>
+            <a:endParaRPr lang="en-US" sz="750" dirty="0"/>
+          </a:p>
+        </p:txBody>
+      </p:sp>
+      <p:sp>
+        <p:nvSpPr>
+          <p:cNvPr id="41" name="Text 39"/>
+          <p:cNvSpPr txBox="1"/>
+          <p:nvPr/>
+        </p:nvSpPr>
+        <p:spPr>
+          <a:xfrm>
+            <a:off x="2651760" y="4224528"/>
+            <a:ext cx="9052560" cy="182880"/>
+          </a:xfrm>
+          <a:prstGeom prst="rect">
+            <a:avLst/>
+          </a:prstGeom>
+          <a:noFill/>
+          <a:ln/>
+        </p:spPr>
+        <p:txBody>
+          <a:bodyPr wrap="square" lIns="0" tIns="0" rIns="0" bIns="0" rtlCol="0" anchor="ctr"/>
+          <a:lstStyle/>
+          <a:p>
+            <a:pPr algn="l" indent="0" marL="0">
+              <a:buNone/>
+            </a:pPr>
+            <a:r>
+              <a:rPr lang="en-US" sz="850" i="1" dirty="0">
+                <a:solidFill>
+                  <a:srgbClr val="898781"/>
+                </a:solidFill>
+                <a:latin typeface="Arial" pitchFamily="34" charset="0"/>
+                <a:ea typeface="Arial" pitchFamily="34" charset="-122"/>
+                <a:cs typeface="Arial" pitchFamily="34" charset="-120"/>
+              </a:rPr>
+              <a:t>Las barras empiezan al NACER; el anillo marca la entrada a la ELPI y el punto lleno, la medición que usa la regresión.</a:t>
+            </a:r>
+            <a:endParaRPr lang="en-US" sz="850" dirty="0"/>
+          </a:p>
+        </p:txBody>
+      </p:sp>
+      <p:sp>
+        <p:nvSpPr>
+          <p:cNvPr id="42" name="Shape 40"/>
+          <p:cNvSpPr/>
+          <p:nvPr/>
+        </p:nvSpPr>
+        <p:spPr>
+          <a:xfrm>
             <a:off x="457200" y="4617720"/>
             <a:ext cx="3630168" cy="1645920"/>
           </a:xfrm>
@@ -9637,7 +9740,7 @@
       </p:sp>
       <p:sp>
         <p:nvSpPr>
-          <p:cNvPr id="40" name="Text 38"/>
+          <p:cNvPr id="43" name="Text 41"/>
           <p:cNvSpPr txBox="1"/>
           <p:nvPr/>
         </p:nvSpPr>
@@ -9676,7 +9779,7 @@
       </p:sp>
       <p:sp>
         <p:nvSpPr>
-          <p:cNvPr id="41" name="Text 39"/>
+          <p:cNvPr id="44" name="Text 42"/>
           <p:cNvSpPr txBox="1"/>
           <p:nvPr/>
         </p:nvSpPr>
@@ -9718,7 +9821,7 @@
       </p:sp>
       <p:sp>
         <p:nvSpPr>
-          <p:cNvPr id="42" name="Shape 40"/>
+          <p:cNvPr id="45" name="Shape 43"/>
           <p:cNvSpPr/>
           <p:nvPr/>
         </p:nvSpPr>
@@ -9740,7 +9843,7 @@
       </p:sp>
       <p:sp>
         <p:nvSpPr>
-          <p:cNvPr id="43" name="Text 41"/>
+          <p:cNvPr id="46" name="Text 44"/>
           <p:cNvSpPr txBox="1"/>
           <p:nvPr/>
         </p:nvSpPr>
@@ -9779,7 +9882,7 @@
       </p:sp>
       <p:sp>
         <p:nvSpPr>
-          <p:cNvPr id="44" name="Text 42"/>
+          <p:cNvPr id="47" name="Text 45"/>
           <p:cNvSpPr txBox="1"/>
           <p:nvPr/>
         </p:nvSpPr>
@@ -9821,7 +9924,7 @@
       </p:sp>
       <p:sp>
         <p:nvSpPr>
-          <p:cNvPr id="45" name="Shape 43"/>
+          <p:cNvPr id="48" name="Shape 46"/>
           <p:cNvSpPr/>
           <p:nvPr/>
         </p:nvSpPr>
@@ -9843,7 +9946,7 @@
       </p:sp>
       <p:sp>
         <p:nvSpPr>
-          <p:cNvPr id="46" name="Text 44"/>
+          <p:cNvPr id="49" name="Text 47"/>
           <p:cNvSpPr txBox="1"/>
           <p:nvPr/>
         </p:nvSpPr>
@@ -9882,7 +9985,7 @@
       </p:sp>
       <p:sp>
         <p:nvSpPr>
-          <p:cNvPr id="47" name="Text 45"/>
+          <p:cNvPr id="50" name="Text 48"/>
           <p:cNvSpPr txBox="1"/>
           <p:nvPr/>
         </p:nvSpPr>
@@ -9924,7 +10027,7 @@
       </p:sp>
       <p:sp>
         <p:nvSpPr>
-          <p:cNvPr id="48" name="Text 46"/>
+          <p:cNvPr id="51" name="Text 49"/>
           <p:cNvSpPr txBox="1"/>
           <p:nvPr/>
         </p:nvSpPr>

</xml_diff>

<commit_message>
Diapo 6: anota la ventana fina (nacidos <=2010 vs 2011)
Co-Authored-By: Claude Fable 5 <noreply@anthropic.com>
Claude-Session: https://claude.ai/code/session_01UqKvCdoWhpNY2WRQ7PFfps
</commit_message>
<xml_diff>
--- a/docs/presentacion_elpi_gillmore.pptx
+++ b/docs/presentacion_elpi_gillmore.pptx
@@ -9724,6 +9724,92 @@
         </p:nvSpPr>
         <p:spPr>
           <a:xfrm>
+            <a:off x="8485632" y="2231136"/>
+            <a:ext cx="2432304" cy="658368"/>
+          </a:xfrm>
+          <a:prstGeom prst="roundRect">
+            <a:avLst>
+              <a:gd name="adj" fmla="val 6944"/>
+            </a:avLst>
+          </a:prstGeom>
+          <a:solidFill>
+            <a:srgbClr val="FFFFFF"/>
+          </a:solidFill>
+          <a:ln w="12700">
+            <a:solidFill>
+              <a:srgbClr val="1E3D5C"/>
+            </a:solidFill>
+            <a:prstDash val="dash"/>
+          </a:ln>
+        </p:spPr>
+      </p:sp>
+      <p:sp>
+        <p:nvSpPr>
+          <p:cNvPr id="43" name="Text 41"/>
+          <p:cNvSpPr txBox="1"/>
+          <p:nvPr/>
+        </p:nvSpPr>
+        <p:spPr>
+          <a:xfrm>
+            <a:off x="8577072" y="2286000"/>
+            <a:ext cx="2267712" cy="566928"/>
+          </a:xfrm>
+          <a:prstGeom prst="rect">
+            <a:avLst/>
+          </a:prstGeom>
+          <a:noFill/>
+          <a:ln/>
+        </p:spPr>
+        <p:txBody>
+          <a:bodyPr wrap="square" lIns="0" tIns="0" rIns="0" bIns="0" rtlCol="0" anchor="t"/>
+          <a:lstStyle/>
+          <a:p>
+            <a:pPr algn="l" indent="0" marL="0">
+              <a:lnSpc>
+                <a:spcPct val="102000"/>
+              </a:lnSpc>
+              <a:buNone/>
+            </a:pPr>
+            <a:r>
+              <a:rPr lang="en-US" sz="780" b="1" dirty="0">
+                <a:solidFill>
+                  <a:srgbClr val="1E3D5C"/>
+                </a:solidFill>
+                <a:latin typeface="Arial" pitchFamily="34" charset="0"/>
+                <a:ea typeface="Arial" pitchFamily="34" charset="-122"/>
+                <a:cs typeface="Arial" pitchFamily="34" charset="-120"/>
+              </a:rPr>
+              <a:t>La ventana fina: </a:t>
+            </a:r>
+            <a:pPr algn="l" indent="0" marL="0">
+              <a:lnSpc>
+                <a:spcPct val="102000"/>
+              </a:lnSpc>
+              <a:buNone/>
+            </a:pPr>
+            <a:r>
+              <a:rPr lang="en-US" sz="780" dirty="0">
+                <a:solidFill>
+                  <a:srgbClr val="52514E"/>
+                </a:solidFill>
+                <a:latin typeface="Arial" pitchFamily="34" charset="0"/>
+                <a:ea typeface="Arial" pitchFamily="34" charset="-122"/>
+                <a:cs typeface="Arial" pitchFamily="34" charset="-120"/>
+              </a:rPr>
+              <a:t>nacidos ≤2010 vs 2011 — 12 meses aparte. A los de 2011 se les testea en 2017, a la misma edad. Gillmore C.31: −0,25 DE.</a:t>
+            </a:r>
+            <a:endParaRPr lang="en-US" sz="780" dirty="0"/>
+          </a:p>
+        </p:txBody>
+      </p:sp>
+      <p:sp>
+        <p:nvSpPr>
+          <p:cNvPr id="44" name="Shape 42"/>
+          <p:cNvSpPr/>
+          <p:nvPr/>
+        </p:nvSpPr>
+        <p:spPr>
+          <a:xfrm>
             <a:off x="457200" y="4617720"/>
             <a:ext cx="3630168" cy="1645920"/>
           </a:xfrm>
@@ -9740,7 +9826,7 @@
       </p:sp>
       <p:sp>
         <p:nvSpPr>
-          <p:cNvPr id="43" name="Text 41"/>
+          <p:cNvPr id="45" name="Text 43"/>
           <p:cNvSpPr txBox="1"/>
           <p:nvPr/>
         </p:nvSpPr>
@@ -9779,7 +9865,7 @@
       </p:sp>
       <p:sp>
         <p:nvSpPr>
-          <p:cNvPr id="44" name="Text 42"/>
+          <p:cNvPr id="46" name="Text 44"/>
           <p:cNvSpPr txBox="1"/>
           <p:nvPr/>
         </p:nvSpPr>
@@ -9821,7 +9907,7 @@
       </p:sp>
       <p:sp>
         <p:nvSpPr>
-          <p:cNvPr id="45" name="Shape 43"/>
+          <p:cNvPr id="47" name="Shape 45"/>
           <p:cNvSpPr/>
           <p:nvPr/>
         </p:nvSpPr>
@@ -9843,7 +9929,7 @@
       </p:sp>
       <p:sp>
         <p:nvSpPr>
-          <p:cNvPr id="46" name="Text 44"/>
+          <p:cNvPr id="48" name="Text 46"/>
           <p:cNvSpPr txBox="1"/>
           <p:nvPr/>
         </p:nvSpPr>
@@ -9882,7 +9968,7 @@
       </p:sp>
       <p:sp>
         <p:nvSpPr>
-          <p:cNvPr id="47" name="Text 45"/>
+          <p:cNvPr id="49" name="Text 47"/>
           <p:cNvSpPr txBox="1"/>
           <p:nvPr/>
         </p:nvSpPr>
@@ -9924,7 +10010,7 @@
       </p:sp>
       <p:sp>
         <p:nvSpPr>
-          <p:cNvPr id="48" name="Shape 46"/>
+          <p:cNvPr id="50" name="Shape 48"/>
           <p:cNvSpPr/>
           <p:nvPr/>
         </p:nvSpPr>
@@ -9946,7 +10032,7 @@
       </p:sp>
       <p:sp>
         <p:nvSpPr>
-          <p:cNvPr id="49" name="Text 47"/>
+          <p:cNvPr id="51" name="Text 49"/>
           <p:cNvSpPr txBox="1"/>
           <p:nvPr/>
         </p:nvSpPr>
@@ -9985,7 +10071,7 @@
       </p:sp>
       <p:sp>
         <p:nvSpPr>
-          <p:cNvPr id="50" name="Text 48"/>
+          <p:cNvPr id="52" name="Text 50"/>
           <p:cNvSpPr txBox="1"/>
           <p:nvPr/>
         </p:nvSpPr>
@@ -10027,7 +10113,7 @@
       </p:sp>
       <p:sp>
         <p:nvSpPr>
-          <p:cNvPr id="51" name="Text 49"/>
+          <p:cNvPr id="53" name="Text 51"/>
           <p:cNvSpPr txBox="1"/>
           <p:nvPr/>
         </p:nvSpPr>

</xml_diff>

<commit_message>
Diapo 6 v3: cuatro filas (original, refresco-2012 tratado y control, refresco-2017) + ola 2010
Corrige además el punto 2024 de los nacidos-2010 (no re-entrevistados).

Co-Authored-By: Claude Fable 5 <noreply@anthropic.com>
Claude-Session: https://claude.ai/code/session_01UqKvCdoWhpNY2WRQ7PFfps
</commit_message>
<xml_diff>
--- a/docs/presentacion_elpi_gillmore.pptx
+++ b/docs/presentacion_elpi_gillmore.pptx
@@ -947,7 +947,7 @@
           <a:p>
             <a:r>
               <a:rPr lang="en-US" dirty="0"/>
-              <a:t>Diagrama del diseno de Gillmore: fila tratada (2006-nov2010) medida en 2012 (2-6, corto), 2017 (7-11, mediano) y 2024 (14-18, largo); filas de control nacidas post-27F via refrescos, medidas en 2017 y NO re-entrevistadas en 2024; banda roja = 27-F.</a:t>
+              <a:t>Version 4 filas: original (2006-09, unica seguida a 2024), refresco-2012 tratado (nacidos 2010), refresco-2012 control (nacidos 2011), refresco-2017 control (2012-15). Ola 2010 = solo linea base. Anillo=entrada; punto=test usado; X=no re-entrevistado 2024.</a:t>
             </a:r>
             <a:endParaRPr lang="en-US" dirty="0"/>
           </a:p>
@@ -8354,24 +8354,24 @@
         </p:nvSpPr>
         <p:spPr>
           <a:xfrm>
-            <a:off x="457200" y="237744"/>
-            <a:ext cx="11274552" cy="493776"/>
-          </a:xfrm>
-          <a:prstGeom prst="rect">
-            <a:avLst/>
-          </a:prstGeom>
-          <a:noFill/>
-          <a:ln/>
-        </p:spPr>
-        <p:txBody>
-          <a:bodyPr wrap="square" lIns="0" tIns="0" rIns="0" bIns="0" rtlCol="0" anchor="ctr"/>
-          <a:lstStyle/>
-          <a:p>
-            <a:pPr algn="l" indent="0" marL="0">
-              <a:buNone/>
-            </a:pPr>
-            <a:r>
-              <a:rPr lang="en-US" sz="3000" b="1" dirty="0">
+            <a:off x="457200" y="219456"/>
+            <a:ext cx="11274552" cy="457200"/>
+          </a:xfrm>
+          <a:prstGeom prst="rect">
+            <a:avLst/>
+          </a:prstGeom>
+          <a:noFill/>
+          <a:ln/>
+        </p:spPr>
+        <p:txBody>
+          <a:bodyPr wrap="square" lIns="0" tIns="0" rIns="0" bIns="0" rtlCol="0" anchor="ctr"/>
+          <a:lstStyle/>
+          <a:p>
+            <a:pPr algn="l" indent="0" marL="0">
+              <a:buNone/>
+            </a:pPr>
+            <a:r>
+              <a:rPr lang="en-US" sz="2900" b="1" dirty="0">
                 <a:solidFill>
                   <a:srgbClr val="0B0B0B"/>
                 </a:solidFill>
@@ -8381,7 +8381,7 @@
               </a:rPr>
               <a:t>El DiD de Gillmore: cohortes, olas y edades</a:t>
             </a:r>
-            <a:endParaRPr lang="en-US" sz="3000" dirty="0"/>
+            <a:endParaRPr lang="en-US" sz="2900" dirty="0"/>
           </a:p>
         </p:txBody>
       </p:sp>
@@ -8393,24 +8393,24 @@
         </p:nvSpPr>
         <p:spPr>
           <a:xfrm>
-            <a:off x="457200" y="786384"/>
-            <a:ext cx="11274552" cy="292608"/>
-          </a:xfrm>
-          <a:prstGeom prst="rect">
-            <a:avLst/>
-          </a:prstGeom>
-          <a:noFill/>
-          <a:ln/>
-        </p:spPr>
-        <p:txBody>
-          <a:bodyPr wrap="square" lIns="0" tIns="0" rIns="0" bIns="0" rtlCol="0" anchor="ctr"/>
-          <a:lstStyle/>
-          <a:p>
-            <a:pPr algn="l" indent="0" marL="0">
-              <a:buNone/>
-            </a:pPr>
-            <a:r>
-              <a:rPr lang="en-US" sz="1150" dirty="0">
+            <a:off x="457200" y="731520"/>
+            <a:ext cx="11274552" cy="274320"/>
+          </a:xfrm>
+          <a:prstGeom prst="rect">
+            <a:avLst/>
+          </a:prstGeom>
+          <a:noFill/>
+          <a:ln/>
+        </p:spPr>
+        <p:txBody>
+          <a:bodyPr wrap="square" lIns="0" tIns="0" rIns="0" bIns="0" rtlCol="0" anchor="ctr"/>
+          <a:lstStyle/>
+          <a:p>
+            <a:pPr algn="l" indent="0" marL="0">
+              <a:buNone/>
+            </a:pPr>
+            <a:r>
+              <a:rPr lang="en-US" sz="1100" dirty="0">
                 <a:solidFill>
                   <a:srgbClr val="52514E"/>
                 </a:solidFill>
@@ -8418,9 +8418,9 @@
                 <a:ea typeface="Arial" pitchFamily="34" charset="-122"/>
                 <a:cs typeface="Arial" pitchFamily="34" charset="-120"/>
               </a:rPr>
-              <a:t>Affected = 1 si el niño tenía 0–4 años (o estaba en gestación) el 27-F. El grupo de control —concebidos después— solo existe gracias a los refrescos… y no fue re-entrevistado en 2024.</a:t>
-            </a:r>
-            <a:endParaRPr lang="en-US" sz="1150" dirty="0"/>
+              <a:t>Cuatro grupos, no dos: la muestra original y la mitad tratada del refresco 2012 (Affected = 1), y las dos tandas concebidas después del 27-F (Affected = 0). Solo la original llega a 2024.</a:t>
+            </a:r>
+            <a:endParaRPr lang="en-US" sz="1100" dirty="0"/>
           </a:p>
         </p:txBody>
       </p:sp>
@@ -8432,8 +8432,69 @@
         </p:nvSpPr>
         <p:spPr>
           <a:xfrm>
-            <a:off x="5366796" y="1444752"/>
-            <a:ext cx="603504" cy="3054096"/>
+            <a:off x="4685751" y="1353312"/>
+            <a:ext cx="457200" cy="2907792"/>
+          </a:xfrm>
+          <a:prstGeom prst="roundRect">
+            <a:avLst>
+              <a:gd name="adj" fmla="val 10000"/>
+            </a:avLst>
+          </a:prstGeom>
+          <a:solidFill>
+            <a:srgbClr val="EDF3FC"/>
+          </a:solidFill>
+          <a:ln/>
+        </p:spPr>
+      </p:sp>
+      <p:sp>
+        <p:nvSpPr>
+          <p:cNvPr id="5" name="Text 3"/>
+          <p:cNvSpPr txBox="1"/>
+          <p:nvPr/>
+        </p:nvSpPr>
+        <p:spPr>
+          <a:xfrm>
+            <a:off x="4274271" y="1133856"/>
+            <a:ext cx="1280160" cy="182880"/>
+          </a:xfrm>
+          <a:prstGeom prst="rect">
+            <a:avLst/>
+          </a:prstGeom>
+          <a:noFill/>
+          <a:ln/>
+        </p:spPr>
+        <p:txBody>
+          <a:bodyPr wrap="square" lIns="0" tIns="0" rIns="0" bIns="0" rtlCol="0" anchor="ctr"/>
+          <a:lstStyle/>
+          <a:p>
+            <a:pPr algn="ctr" indent="0" marL="0">
+              <a:buNone/>
+            </a:pPr>
+            <a:r>
+              <a:rPr lang="en-US" sz="900" b="1" dirty="0">
+                <a:solidFill>
+                  <a:srgbClr val="1E3D5C"/>
+                </a:solidFill>
+                <a:latin typeface="Arial" pitchFamily="34" charset="0"/>
+                <a:ea typeface="Arial" pitchFamily="34" charset="-122"/>
+                <a:cs typeface="Arial" pitchFamily="34" charset="-120"/>
+              </a:rPr>
+              <a:t>OLA 2010</a:t>
+            </a:r>
+            <a:endParaRPr lang="en-US" sz="900" dirty="0"/>
+          </a:p>
+        </p:txBody>
+      </p:sp>
+      <p:sp>
+        <p:nvSpPr>
+          <p:cNvPr id="6" name="Shape 4"/>
+          <p:cNvSpPr/>
+          <p:nvPr/>
+        </p:nvSpPr>
+        <p:spPr>
+          <a:xfrm>
+            <a:off x="5366796" y="1353312"/>
+            <a:ext cx="603504" cy="2907792"/>
           </a:xfrm>
           <a:prstGeom prst="roundRect">
             <a:avLst>
@@ -8448,14 +8509,14 @@
       </p:sp>
       <p:sp>
         <p:nvSpPr>
-          <p:cNvPr id="5" name="Text 3"/>
-          <p:cNvSpPr txBox="1"/>
-          <p:nvPr/>
-        </p:nvSpPr>
-        <p:spPr>
-          <a:xfrm>
-            <a:off x="5028468" y="1207008"/>
-            <a:ext cx="1280160" cy="201168"/>
+          <p:cNvPr id="7" name="Text 5"/>
+          <p:cNvSpPr txBox="1"/>
+          <p:nvPr/>
+        </p:nvSpPr>
+        <p:spPr>
+          <a:xfrm>
+            <a:off x="5028468" y="1133856"/>
+            <a:ext cx="1280160" cy="182880"/>
           </a:xfrm>
           <a:prstGeom prst="rect">
             <a:avLst/>
@@ -8471,7 +8532,7 @@
               <a:buNone/>
             </a:pPr>
             <a:r>
-              <a:rPr lang="en-US" sz="950" b="1" dirty="0">
+              <a:rPr lang="en-US" sz="900" b="1" dirty="0">
                 <a:solidFill>
                   <a:srgbClr val="1E3D5C"/>
                 </a:solidFill>
@@ -8481,20 +8542,20 @@
               </a:rPr>
               <a:t>OLA 2012</a:t>
             </a:r>
-            <a:endParaRPr lang="en-US" sz="950" dirty="0"/>
-          </a:p>
-        </p:txBody>
-      </p:sp>
-      <p:sp>
-        <p:nvSpPr>
-          <p:cNvPr id="6" name="Shape 4"/>
+            <a:endParaRPr lang="en-US" sz="900" dirty="0"/>
+          </a:p>
+        </p:txBody>
+      </p:sp>
+      <p:sp>
+        <p:nvSpPr>
+          <p:cNvPr id="8" name="Shape 6"/>
           <p:cNvSpPr/>
           <p:nvPr/>
         </p:nvSpPr>
         <p:spPr>
           <a:xfrm>
-            <a:off x="7723662" y="1444752"/>
-            <a:ext cx="603504" cy="3054096"/>
+            <a:off x="7723662" y="1353312"/>
+            <a:ext cx="603504" cy="2907792"/>
           </a:xfrm>
           <a:prstGeom prst="roundRect">
             <a:avLst>
@@ -8509,14 +8570,14 @@
       </p:sp>
       <p:sp>
         <p:nvSpPr>
-          <p:cNvPr id="7" name="Text 5"/>
-          <p:cNvSpPr txBox="1"/>
-          <p:nvPr/>
-        </p:nvSpPr>
-        <p:spPr>
-          <a:xfrm>
-            <a:off x="7385334" y="1207008"/>
-            <a:ext cx="1280160" cy="201168"/>
+          <p:cNvPr id="9" name="Text 7"/>
+          <p:cNvSpPr txBox="1"/>
+          <p:nvPr/>
+        </p:nvSpPr>
+        <p:spPr>
+          <a:xfrm>
+            <a:off x="7385334" y="1133856"/>
+            <a:ext cx="1280160" cy="182880"/>
           </a:xfrm>
           <a:prstGeom prst="rect">
             <a:avLst/>
@@ -8532,7 +8593,7 @@
               <a:buNone/>
             </a:pPr>
             <a:r>
-              <a:rPr lang="en-US" sz="950" b="1" dirty="0">
+              <a:rPr lang="en-US" sz="900" b="1" dirty="0">
                 <a:solidFill>
                   <a:srgbClr val="1E3D5C"/>
                 </a:solidFill>
@@ -8542,20 +8603,20 @@
               </a:rPr>
               <a:t>OLA 2017</a:t>
             </a:r>
-            <a:endParaRPr lang="en-US" sz="950" dirty="0"/>
-          </a:p>
-        </p:txBody>
-      </p:sp>
-      <p:sp>
-        <p:nvSpPr>
-          <p:cNvPr id="8" name="Shape 6"/>
+            <a:endParaRPr lang="en-US" sz="900" dirty="0"/>
+          </a:p>
+        </p:txBody>
+      </p:sp>
+      <p:sp>
+        <p:nvSpPr>
+          <p:cNvPr id="10" name="Shape 8"/>
           <p:cNvSpPr/>
           <p:nvPr/>
         </p:nvSpPr>
         <p:spPr>
           <a:xfrm>
-            <a:off x="10976138" y="1444752"/>
-            <a:ext cx="603504" cy="3054096"/>
+            <a:off x="10976138" y="1353312"/>
+            <a:ext cx="603504" cy="2907792"/>
           </a:xfrm>
           <a:prstGeom prst="roundRect">
             <a:avLst>
@@ -8570,14 +8631,14 @@
       </p:sp>
       <p:sp>
         <p:nvSpPr>
-          <p:cNvPr id="9" name="Text 7"/>
-          <p:cNvSpPr txBox="1"/>
-          <p:nvPr/>
-        </p:nvSpPr>
-        <p:spPr>
-          <a:xfrm>
-            <a:off x="10637810" y="1207008"/>
-            <a:ext cx="1280160" cy="201168"/>
+          <p:cNvPr id="11" name="Text 9"/>
+          <p:cNvSpPr txBox="1"/>
+          <p:nvPr/>
+        </p:nvSpPr>
+        <p:spPr>
+          <a:xfrm>
+            <a:off x="10637810" y="1133856"/>
+            <a:ext cx="1280160" cy="182880"/>
           </a:xfrm>
           <a:prstGeom prst="rect">
             <a:avLst/>
@@ -8593,7 +8654,7 @@
               <a:buNone/>
             </a:pPr>
             <a:r>
-              <a:rPr lang="en-US" sz="950" b="1" dirty="0">
+              <a:rPr lang="en-US" sz="900" b="1" dirty="0">
                 <a:solidFill>
                   <a:srgbClr val="1E3D5C"/>
                 </a:solidFill>
@@ -8603,20 +8664,20 @@
               </a:rPr>
               <a:t>OLA 2024</a:t>
             </a:r>
-            <a:endParaRPr lang="en-US" sz="950" dirty="0"/>
-          </a:p>
-        </p:txBody>
-      </p:sp>
-      <p:sp>
-        <p:nvSpPr>
-          <p:cNvPr id="10" name="Shape 8"/>
+            <a:endParaRPr lang="en-US" sz="900" dirty="0"/>
+          </a:p>
+        </p:txBody>
+      </p:sp>
+      <p:sp>
+        <p:nvSpPr>
+          <p:cNvPr id="12" name="Shape 10"/>
           <p:cNvSpPr/>
           <p:nvPr/>
         </p:nvSpPr>
         <p:spPr>
           <a:xfrm>
-            <a:off x="4594243" y="1371600"/>
-            <a:ext cx="27432" cy="3200400"/>
+            <a:off x="4594243" y="1280160"/>
+            <a:ext cx="27432" cy="3090672"/>
           </a:xfrm>
           <a:prstGeom prst="rect">
             <a:avLst/>
@@ -8629,14 +8690,14 @@
       </p:sp>
       <p:sp>
         <p:nvSpPr>
-          <p:cNvPr id="11" name="Text 9"/>
-          <p:cNvSpPr txBox="1"/>
-          <p:nvPr/>
-        </p:nvSpPr>
-        <p:spPr>
-          <a:xfrm>
-            <a:off x="3876439" y="1005840"/>
-            <a:ext cx="1463040" cy="182880"/>
+          <p:cNvPr id="13" name="Text 11"/>
+          <p:cNvSpPr txBox="1"/>
+          <p:nvPr/>
+        </p:nvSpPr>
+        <p:spPr>
+          <a:xfrm>
+            <a:off x="4059319" y="950976"/>
+            <a:ext cx="1097280" cy="164592"/>
           </a:xfrm>
           <a:prstGeom prst="rect">
             <a:avLst/>
@@ -8652,7 +8713,7 @@
               <a:buNone/>
             </a:pPr>
             <a:r>
-              <a:rPr lang="en-US" sz="950" b="1" dirty="0">
+              <a:rPr lang="en-US" sz="900" b="1" dirty="0">
                 <a:solidFill>
                   <a:srgbClr val="C0392B"/>
                 </a:solidFill>
@@ -8660,26 +8721,26 @@
                 <a:ea typeface="Arial" pitchFamily="34" charset="-122"/>
                 <a:cs typeface="Arial" pitchFamily="34" charset="-120"/>
               </a:rPr>
-              <a:t>27-F (8,8 Mw)</a:t>
-            </a:r>
-            <a:endParaRPr lang="en-US" sz="950" dirty="0"/>
-          </a:p>
-        </p:txBody>
-      </p:sp>
-      <p:sp>
-        <p:nvSpPr>
-          <p:cNvPr id="12" name="Shape 10"/>
+              <a:t>27-F</a:t>
+            </a:r>
+            <a:endParaRPr lang="en-US" sz="900" dirty="0"/>
+          </a:p>
+        </p:txBody>
+      </p:sp>
+      <p:sp>
+        <p:nvSpPr>
+          <p:cNvPr id="14" name="Shape 12"/>
           <p:cNvSpPr/>
           <p:nvPr/>
         </p:nvSpPr>
         <p:spPr>
           <a:xfrm>
-            <a:off x="2651760" y="1828800"/>
-            <a:ext cx="9006840" cy="274320"/>
+            <a:off x="2651760" y="1627632"/>
+            <a:ext cx="9006840" cy="256032"/>
           </a:xfrm>
           <a:prstGeom prst="roundRect">
             <a:avLst>
-              <a:gd name="adj" fmla="val 26667"/>
+              <a:gd name="adj" fmla="val 25000"/>
             </a:avLst>
           </a:prstGeom>
           <a:solidFill>
@@ -8695,69 +8756,69 @@
       </p:sp>
       <p:sp>
         <p:nvSpPr>
-          <p:cNvPr id="13" name="Text 11"/>
-          <p:cNvSpPr txBox="1"/>
-          <p:nvPr/>
-        </p:nvSpPr>
-        <p:spPr>
-          <a:xfrm>
-            <a:off x="457200" y="1691640"/>
-            <a:ext cx="2103120" cy="182880"/>
-          </a:xfrm>
-          <a:prstGeom prst="rect">
-            <a:avLst/>
-          </a:prstGeom>
-          <a:noFill/>
-          <a:ln/>
-        </p:spPr>
-        <p:txBody>
-          <a:bodyPr wrap="square" lIns="0" tIns="0" rIns="0" bIns="0" rtlCol="0" anchor="ctr"/>
-          <a:lstStyle/>
-          <a:p>
-            <a:pPr algn="l" indent="0" marL="0">
-              <a:buNone/>
-            </a:pPr>
-            <a:r>
-              <a:rPr lang="en-US" sz="950" b="1" dirty="0">
-                <a:solidFill>
-                  <a:srgbClr val="0B0B0B"/>
-                </a:solidFill>
-                <a:latin typeface="Arial" pitchFamily="34" charset="0"/>
-                <a:ea typeface="Arial" pitchFamily="34" charset="-122"/>
-                <a:cs typeface="Arial" pitchFamily="34" charset="-120"/>
-              </a:rPr>
-              <a:t>AFFECTED = 1</a:t>
-            </a:r>
-            <a:endParaRPr lang="en-US" sz="950" dirty="0"/>
-          </a:p>
-        </p:txBody>
-      </p:sp>
-      <p:sp>
-        <p:nvSpPr>
-          <p:cNvPr id="14" name="Text 12"/>
-          <p:cNvSpPr txBox="1"/>
-          <p:nvPr/>
-        </p:nvSpPr>
-        <p:spPr>
-          <a:xfrm>
-            <a:off x="457200" y="1883664"/>
-            <a:ext cx="2103120" cy="384048"/>
-          </a:xfrm>
-          <a:prstGeom prst="rect">
-            <a:avLst/>
-          </a:prstGeom>
-          <a:noFill/>
-          <a:ln/>
-        </p:spPr>
-        <p:txBody>
-          <a:bodyPr wrap="square" lIns="0" tIns="0" rIns="0" bIns="0" rtlCol="0" anchor="ctr"/>
-          <a:lstStyle/>
-          <a:p>
-            <a:pPr algn="l" indent="0" marL="0">
-              <a:buNone/>
-            </a:pPr>
-            <a:r>
-              <a:rPr lang="en-US" sz="800" dirty="0">
+          <p:cNvPr id="15" name="Text 13"/>
+          <p:cNvSpPr txBox="1"/>
+          <p:nvPr/>
+        </p:nvSpPr>
+        <p:spPr>
+          <a:xfrm>
+            <a:off x="457200" y="1508760"/>
+            <a:ext cx="2121408" cy="155448"/>
+          </a:xfrm>
+          <a:prstGeom prst="rect">
+            <a:avLst/>
+          </a:prstGeom>
+          <a:noFill/>
+          <a:ln/>
+        </p:spPr>
+        <p:txBody>
+          <a:bodyPr wrap="square" lIns="0" tIns="0" rIns="0" bIns="0" rtlCol="0" anchor="ctr"/>
+          <a:lstStyle/>
+          <a:p>
+            <a:pPr algn="l" indent="0" marL="0">
+              <a:buNone/>
+            </a:pPr>
+            <a:r>
+              <a:rPr lang="en-US" sz="860" b="1" dirty="0">
+                <a:solidFill>
+                  <a:srgbClr val="1E3D5C"/>
+                </a:solidFill>
+                <a:latin typeface="Arial" pitchFamily="34" charset="0"/>
+                <a:ea typeface="Arial" pitchFamily="34" charset="-122"/>
+                <a:cs typeface="Arial" pitchFamily="34" charset="-120"/>
+              </a:rPr>
+              <a:t>AFFECTED = 1 · muestra ORIGINAL</a:t>
+            </a:r>
+            <a:endParaRPr lang="en-US" sz="860" dirty="0"/>
+          </a:p>
+        </p:txBody>
+      </p:sp>
+      <p:sp>
+        <p:nvSpPr>
+          <p:cNvPr id="16" name="Text 14"/>
+          <p:cNvSpPr txBox="1"/>
+          <p:nvPr/>
+        </p:nvSpPr>
+        <p:spPr>
+          <a:xfrm>
+            <a:off x="457200" y="1673352"/>
+            <a:ext cx="2121408" cy="402336"/>
+          </a:xfrm>
+          <a:prstGeom prst="rect">
+            <a:avLst/>
+          </a:prstGeom>
+          <a:noFill/>
+          <a:ln/>
+        </p:spPr>
+        <p:txBody>
+          <a:bodyPr wrap="square" lIns="0" tIns="0" rIns="0" bIns="0" rtlCol="0" anchor="ctr"/>
+          <a:lstStyle/>
+          <a:p>
+            <a:pPr algn="l" indent="0" marL="0">
+              <a:buNone/>
+            </a:pPr>
+            <a:r>
+              <a:rPr lang="en-US" sz="740" dirty="0">
                 <a:solidFill>
                   <a:srgbClr val="52514E"/>
                 </a:solidFill>
@@ -8765,22 +8826,125 @@
                 <a:ea typeface="Arial" pitchFamily="34" charset="-122"/>
                 <a:cs typeface="Arial" pitchFamily="34" charset="-120"/>
               </a:rPr>
-              <a:t>Nacidos 2006–nov 2010: 0–4 años el 27-F (los de mar–nov 2010 entran vía refresco 2012)</a:t>
-            </a:r>
-            <a:endParaRPr lang="en-US" sz="800" dirty="0"/>
-          </a:p>
-        </p:txBody>
-      </p:sp>
-      <p:sp>
-        <p:nvSpPr>
-          <p:cNvPr id="15" name="Shape 13"/>
+              <a:t>Nacidos 2006–2009. Entran en 2010 con 0–4. Los únicos seguidos hasta 2024.</a:t>
+            </a:r>
+            <a:endParaRPr lang="en-US" sz="740" dirty="0"/>
+          </a:p>
+        </p:txBody>
+      </p:sp>
+      <p:sp>
+        <p:nvSpPr>
+          <p:cNvPr id="17" name="Shape 15"/>
           <p:cNvSpPr/>
           <p:nvPr/>
         </p:nvSpPr>
         <p:spPr>
           <a:xfrm>
-            <a:off x="5540532" y="1837944"/>
-            <a:ext cx="256032" cy="256032"/>
+            <a:off x="4832055" y="1673352"/>
+            <a:ext cx="164592" cy="164592"/>
+          </a:xfrm>
+          <a:prstGeom prst="ellipse">
+            <a:avLst/>
+          </a:prstGeom>
+          <a:solidFill>
+            <a:srgbClr val="FFFFFF"/>
+          </a:solidFill>
+          <a:ln w="22225">
+            <a:solidFill>
+              <a:srgbClr val="2A78D6"/>
+            </a:solidFill>
+            <a:prstDash val="solid"/>
+          </a:ln>
+        </p:spPr>
+      </p:sp>
+      <p:sp>
+        <p:nvSpPr>
+          <p:cNvPr id="18" name="Text 16"/>
+          <p:cNvSpPr txBox="1"/>
+          <p:nvPr/>
+        </p:nvSpPr>
+        <p:spPr>
+          <a:xfrm>
+            <a:off x="4411431" y="1389888"/>
+            <a:ext cx="1005840" cy="155448"/>
+          </a:xfrm>
+          <a:prstGeom prst="rect">
+            <a:avLst/>
+          </a:prstGeom>
+          <a:noFill/>
+          <a:ln/>
+        </p:spPr>
+        <p:txBody>
+          <a:bodyPr wrap="square" lIns="0" tIns="0" rIns="0" bIns="0" rtlCol="0" anchor="ctr"/>
+          <a:lstStyle/>
+          <a:p>
+            <a:pPr algn="ctr" indent="0" marL="0">
+              <a:buNone/>
+            </a:pPr>
+            <a:r>
+              <a:rPr lang="en-US" sz="900" b="1" dirty="0">
+                <a:solidFill>
+                  <a:srgbClr val="1E3D5C"/>
+                </a:solidFill>
+                <a:latin typeface="Arial" pitchFamily="34" charset="0"/>
+                <a:ea typeface="Arial" pitchFamily="34" charset="-122"/>
+                <a:cs typeface="Arial" pitchFamily="34" charset="-120"/>
+              </a:rPr>
+              <a:t>0–4</a:t>
+            </a:r>
+            <a:endParaRPr lang="en-US" sz="900" dirty="0"/>
+          </a:p>
+        </p:txBody>
+      </p:sp>
+      <p:sp>
+        <p:nvSpPr>
+          <p:cNvPr id="19" name="Text 17"/>
+          <p:cNvSpPr txBox="1"/>
+          <p:nvPr/>
+        </p:nvSpPr>
+        <p:spPr>
+          <a:xfrm>
+            <a:off x="4137111" y="1901952"/>
+            <a:ext cx="1554480" cy="146304"/>
+          </a:xfrm>
+          <a:prstGeom prst="rect">
+            <a:avLst/>
+          </a:prstGeom>
+          <a:noFill/>
+          <a:ln/>
+        </p:spPr>
+        <p:txBody>
+          <a:bodyPr wrap="square" lIns="0" tIns="0" rIns="0" bIns="0" rtlCol="0" anchor="ctr"/>
+          <a:lstStyle/>
+          <a:p>
+            <a:pPr algn="ctr" indent="0" marL="0">
+              <a:buNone/>
+            </a:pPr>
+            <a:r>
+              <a:rPr lang="en-US" sz="720" i="1" dirty="0">
+                <a:solidFill>
+                  <a:srgbClr val="898781"/>
+                </a:solidFill>
+                <a:latin typeface="Arial" pitchFamily="34" charset="0"/>
+                <a:ea typeface="Arial" pitchFamily="34" charset="-122"/>
+                <a:cs typeface="Arial" pitchFamily="34" charset="-120"/>
+              </a:rPr>
+              <a:t>entra · solo línea base</a:t>
+            </a:r>
+            <a:endParaRPr lang="en-US" sz="720" dirty="0"/>
+          </a:p>
+        </p:txBody>
+      </p:sp>
+      <p:sp>
+        <p:nvSpPr>
+          <p:cNvPr id="20" name="Shape 18"/>
+          <p:cNvSpPr/>
+          <p:nvPr/>
+        </p:nvSpPr>
+        <p:spPr>
+          <a:xfrm>
+            <a:off x="5554248" y="1641348"/>
+            <a:ext cx="228600" cy="228600"/>
           </a:xfrm>
           <a:prstGeom prst="ellipse">
             <a:avLst/>
@@ -8798,14 +8962,14 @@
       </p:sp>
       <p:sp>
         <p:nvSpPr>
-          <p:cNvPr id="16" name="Text 14"/>
-          <p:cNvSpPr txBox="1"/>
-          <p:nvPr/>
-        </p:nvSpPr>
-        <p:spPr>
-          <a:xfrm>
-            <a:off x="5165628" y="1536192"/>
-            <a:ext cx="1005840" cy="182880"/>
+          <p:cNvPr id="21" name="Text 19"/>
+          <p:cNvSpPr txBox="1"/>
+          <p:nvPr/>
+        </p:nvSpPr>
+        <p:spPr>
+          <a:xfrm>
+            <a:off x="5165628" y="1389888"/>
+            <a:ext cx="1005840" cy="155448"/>
           </a:xfrm>
           <a:prstGeom prst="rect">
             <a:avLst/>
@@ -8821,7 +8985,7 @@
               <a:buNone/>
             </a:pPr>
             <a:r>
-              <a:rPr lang="en-US" sz="1000" b="1" dirty="0">
+              <a:rPr lang="en-US" sz="900" b="1" dirty="0">
                 <a:solidFill>
                   <a:srgbClr val="1E3D5C"/>
                 </a:solidFill>
@@ -8831,20 +8995,20 @@
               </a:rPr>
               <a:t>2–6</a:t>
             </a:r>
-            <a:endParaRPr lang="en-US" sz="1000" dirty="0"/>
-          </a:p>
-        </p:txBody>
-      </p:sp>
-      <p:sp>
-        <p:nvSpPr>
-          <p:cNvPr id="17" name="Text 15"/>
-          <p:cNvSpPr txBox="1"/>
-          <p:nvPr/>
-        </p:nvSpPr>
-        <p:spPr>
-          <a:xfrm>
-            <a:off x="5119908" y="2148840"/>
-            <a:ext cx="1097280" cy="164592"/>
+            <a:endParaRPr lang="en-US" sz="900" dirty="0"/>
+          </a:p>
+        </p:txBody>
+      </p:sp>
+      <p:sp>
+        <p:nvSpPr>
+          <p:cNvPr id="22" name="Text 20"/>
+          <p:cNvSpPr txBox="1"/>
+          <p:nvPr/>
+        </p:nvSpPr>
+        <p:spPr>
+          <a:xfrm>
+            <a:off x="4891308" y="1901952"/>
+            <a:ext cx="1554480" cy="146304"/>
           </a:xfrm>
           <a:prstGeom prst="rect">
             <a:avLst/>
@@ -8860,7 +9024,7 @@
               <a:buNone/>
             </a:pPr>
             <a:r>
-              <a:rPr lang="en-US" sz="800" dirty="0">
+              <a:rPr lang="en-US" sz="720" i="1" dirty="0">
                 <a:solidFill>
                   <a:srgbClr val="898781"/>
                 </a:solidFill>
@@ -8870,20 +9034,20 @@
               </a:rPr>
               <a:t>corto plazo</a:t>
             </a:r>
-            <a:endParaRPr lang="en-US" sz="800" dirty="0"/>
-          </a:p>
-        </p:txBody>
-      </p:sp>
-      <p:sp>
-        <p:nvSpPr>
-          <p:cNvPr id="18" name="Shape 16"/>
+            <a:endParaRPr lang="en-US" sz="720" dirty="0"/>
+          </a:p>
+        </p:txBody>
+      </p:sp>
+      <p:sp>
+        <p:nvSpPr>
+          <p:cNvPr id="23" name="Shape 21"/>
           <p:cNvSpPr/>
           <p:nvPr/>
         </p:nvSpPr>
         <p:spPr>
           <a:xfrm>
-            <a:off x="7897398" y="1837944"/>
-            <a:ext cx="256032" cy="256032"/>
+            <a:off x="7911114" y="1641348"/>
+            <a:ext cx="228600" cy="228600"/>
           </a:xfrm>
           <a:prstGeom prst="ellipse">
             <a:avLst/>
@@ -8901,14 +9065,14 @@
       </p:sp>
       <p:sp>
         <p:nvSpPr>
-          <p:cNvPr id="19" name="Text 17"/>
-          <p:cNvSpPr txBox="1"/>
-          <p:nvPr/>
-        </p:nvSpPr>
-        <p:spPr>
-          <a:xfrm>
-            <a:off x="7522494" y="1536192"/>
-            <a:ext cx="1005840" cy="182880"/>
+          <p:cNvPr id="24" name="Text 22"/>
+          <p:cNvSpPr txBox="1"/>
+          <p:nvPr/>
+        </p:nvSpPr>
+        <p:spPr>
+          <a:xfrm>
+            <a:off x="7522494" y="1389888"/>
+            <a:ext cx="1005840" cy="155448"/>
           </a:xfrm>
           <a:prstGeom prst="rect">
             <a:avLst/>
@@ -8924,7 +9088,7 @@
               <a:buNone/>
             </a:pPr>
             <a:r>
-              <a:rPr lang="en-US" sz="1000" b="1" dirty="0">
+              <a:rPr lang="en-US" sz="900" b="1" dirty="0">
                 <a:solidFill>
                   <a:srgbClr val="1E3D5C"/>
                 </a:solidFill>
@@ -8932,22 +9096,22 @@
                 <a:ea typeface="Arial" pitchFamily="34" charset="-122"/>
                 <a:cs typeface="Arial" pitchFamily="34" charset="-120"/>
               </a:rPr>
-              <a:t>7–11</a:t>
-            </a:r>
-            <a:endParaRPr lang="en-US" sz="1000" dirty="0"/>
-          </a:p>
-        </p:txBody>
-      </p:sp>
-      <p:sp>
-        <p:nvSpPr>
-          <p:cNvPr id="20" name="Text 18"/>
-          <p:cNvSpPr txBox="1"/>
-          <p:nvPr/>
-        </p:nvSpPr>
-        <p:spPr>
-          <a:xfrm>
-            <a:off x="7476774" y="2148840"/>
-            <a:ext cx="1097280" cy="164592"/>
+              <a:t>8–12</a:t>
+            </a:r>
+            <a:endParaRPr lang="en-US" sz="900" dirty="0"/>
+          </a:p>
+        </p:txBody>
+      </p:sp>
+      <p:sp>
+        <p:nvSpPr>
+          <p:cNvPr id="25" name="Text 23"/>
+          <p:cNvSpPr txBox="1"/>
+          <p:nvPr/>
+        </p:nvSpPr>
+        <p:spPr>
+          <a:xfrm>
+            <a:off x="7248174" y="1901952"/>
+            <a:ext cx="1554480" cy="146304"/>
           </a:xfrm>
           <a:prstGeom prst="rect">
             <a:avLst/>
@@ -8963,7 +9127,7 @@
               <a:buNone/>
             </a:pPr>
             <a:r>
-              <a:rPr lang="en-US" sz="800" dirty="0">
+              <a:rPr lang="en-US" sz="720" i="1" dirty="0">
                 <a:solidFill>
                   <a:srgbClr val="898781"/>
                 </a:solidFill>
@@ -8973,20 +9137,20 @@
               </a:rPr>
               <a:t>mediano</a:t>
             </a:r>
-            <a:endParaRPr lang="en-US" sz="800" dirty="0"/>
-          </a:p>
-        </p:txBody>
-      </p:sp>
-      <p:sp>
-        <p:nvSpPr>
-          <p:cNvPr id="21" name="Shape 19"/>
+            <a:endParaRPr lang="en-US" sz="720" dirty="0"/>
+          </a:p>
+        </p:txBody>
+      </p:sp>
+      <p:sp>
+        <p:nvSpPr>
+          <p:cNvPr id="26" name="Shape 24"/>
           <p:cNvSpPr/>
           <p:nvPr/>
         </p:nvSpPr>
         <p:spPr>
           <a:xfrm>
-            <a:off x="11149874" y="1837944"/>
-            <a:ext cx="256032" cy="256032"/>
+            <a:off x="11163590" y="1641348"/>
+            <a:ext cx="228600" cy="228600"/>
           </a:xfrm>
           <a:prstGeom prst="ellipse">
             <a:avLst/>
@@ -9004,14 +9168,14 @@
       </p:sp>
       <p:sp>
         <p:nvSpPr>
-          <p:cNvPr id="22" name="Text 20"/>
-          <p:cNvSpPr txBox="1"/>
-          <p:nvPr/>
-        </p:nvSpPr>
-        <p:spPr>
-          <a:xfrm>
-            <a:off x="10774970" y="1536192"/>
-            <a:ext cx="1005840" cy="182880"/>
+          <p:cNvPr id="27" name="Text 25"/>
+          <p:cNvSpPr txBox="1"/>
+          <p:nvPr/>
+        </p:nvSpPr>
+        <p:spPr>
+          <a:xfrm>
+            <a:off x="10774970" y="1389888"/>
+            <a:ext cx="1005840" cy="155448"/>
           </a:xfrm>
           <a:prstGeom prst="rect">
             <a:avLst/>
@@ -9027,7 +9191,7 @@
               <a:buNone/>
             </a:pPr>
             <a:r>
-              <a:rPr lang="en-US" sz="1000" b="1" dirty="0">
+              <a:rPr lang="en-US" sz="900" b="1" dirty="0">
                 <a:solidFill>
                   <a:srgbClr val="1E3D5C"/>
                 </a:solidFill>
@@ -9037,20 +9201,20 @@
               </a:rPr>
               <a:t>14–18</a:t>
             </a:r>
-            <a:endParaRPr lang="en-US" sz="1000" dirty="0"/>
-          </a:p>
-        </p:txBody>
-      </p:sp>
-      <p:sp>
-        <p:nvSpPr>
-          <p:cNvPr id="23" name="Text 21"/>
-          <p:cNvSpPr txBox="1"/>
-          <p:nvPr/>
-        </p:nvSpPr>
-        <p:spPr>
-          <a:xfrm>
-            <a:off x="10729250" y="2148840"/>
-            <a:ext cx="1097280" cy="164592"/>
+            <a:endParaRPr lang="en-US" sz="900" dirty="0"/>
+          </a:p>
+        </p:txBody>
+      </p:sp>
+      <p:sp>
+        <p:nvSpPr>
+          <p:cNvPr id="28" name="Text 26"/>
+          <p:cNvSpPr txBox="1"/>
+          <p:nvPr/>
+        </p:nvSpPr>
+        <p:spPr>
+          <a:xfrm>
+            <a:off x="10500650" y="1901952"/>
+            <a:ext cx="1554480" cy="146304"/>
           </a:xfrm>
           <a:prstGeom prst="rect">
             <a:avLst/>
@@ -9066,7 +9230,7 @@
               <a:buNone/>
             </a:pPr>
             <a:r>
-              <a:rPr lang="en-US" sz="800" dirty="0">
+              <a:rPr lang="en-US" sz="720" i="1" dirty="0">
                 <a:solidFill>
                   <a:srgbClr val="898781"/>
                 </a:solidFill>
@@ -9074,26 +9238,376 @@
                 <a:ea typeface="Arial" pitchFamily="34" charset="-122"/>
                 <a:cs typeface="Arial" pitchFamily="34" charset="-120"/>
               </a:rPr>
-              <a:t>largo (2024)</a:t>
-            </a:r>
-            <a:endParaRPr lang="en-US" sz="800" dirty="0"/>
-          </a:p>
-        </p:txBody>
-      </p:sp>
-      <p:sp>
-        <p:nvSpPr>
-          <p:cNvPr id="24" name="Shape 22"/>
+              <a:t>largo (nuestro)</a:t>
+            </a:r>
+            <a:endParaRPr lang="en-US" sz="720" dirty="0"/>
+          </a:p>
+        </p:txBody>
+      </p:sp>
+      <p:sp>
+        <p:nvSpPr>
+          <p:cNvPr id="29" name="Shape 27"/>
           <p:cNvSpPr/>
           <p:nvPr/>
         </p:nvSpPr>
         <p:spPr>
           <a:xfrm>
-            <a:off x="5008626" y="2926080"/>
-            <a:ext cx="6649974" cy="274320"/>
+            <a:off x="4631527" y="2331720"/>
+            <a:ext cx="7027073" cy="256032"/>
           </a:xfrm>
           <a:prstGeom prst="roundRect">
             <a:avLst>
-              <a:gd name="adj" fmla="val 26667"/>
+              <a:gd name="adj" fmla="val 25000"/>
+            </a:avLst>
+          </a:prstGeom>
+          <a:solidFill>
+            <a:srgbClr val="CFE0F6"/>
+          </a:solidFill>
+          <a:ln w="12700">
+            <a:solidFill>
+              <a:srgbClr val="2A78D6"/>
+            </a:solidFill>
+            <a:prstDash val="solid"/>
+          </a:ln>
+        </p:spPr>
+      </p:sp>
+      <p:sp>
+        <p:nvSpPr>
+          <p:cNvPr id="30" name="Text 28"/>
+          <p:cNvSpPr txBox="1"/>
+          <p:nvPr/>
+        </p:nvSpPr>
+        <p:spPr>
+          <a:xfrm>
+            <a:off x="457200" y="2212848"/>
+            <a:ext cx="2121408" cy="155448"/>
+          </a:xfrm>
+          <a:prstGeom prst="rect">
+            <a:avLst/>
+          </a:prstGeom>
+          <a:noFill/>
+          <a:ln/>
+        </p:spPr>
+        <p:txBody>
+          <a:bodyPr wrap="square" lIns="0" tIns="0" rIns="0" bIns="0" rtlCol="0" anchor="ctr"/>
+          <a:lstStyle/>
+          <a:p>
+            <a:pPr algn="l" indent="0" marL="0">
+              <a:buNone/>
+            </a:pPr>
+            <a:r>
+              <a:rPr lang="en-US" sz="860" b="1" dirty="0">
+                <a:solidFill>
+                  <a:srgbClr val="1E3D5C"/>
+                </a:solidFill>
+                <a:latin typeface="Arial" pitchFamily="34" charset="0"/>
+                <a:ea typeface="Arial" pitchFamily="34" charset="-122"/>
+                <a:cs typeface="Arial" pitchFamily="34" charset="-120"/>
+              </a:rPr>
+              <a:t>AFFECTED = 1 · refresco 2012</a:t>
+            </a:r>
+            <a:endParaRPr lang="en-US" sz="860" dirty="0"/>
+          </a:p>
+        </p:txBody>
+      </p:sp>
+      <p:sp>
+        <p:nvSpPr>
+          <p:cNvPr id="31" name="Text 29"/>
+          <p:cNvSpPr txBox="1"/>
+          <p:nvPr/>
+        </p:nvSpPr>
+        <p:spPr>
+          <a:xfrm>
+            <a:off x="457200" y="2377440"/>
+            <a:ext cx="2121408" cy="402336"/>
+          </a:xfrm>
+          <a:prstGeom prst="rect">
+            <a:avLst/>
+          </a:prstGeom>
+          <a:noFill/>
+          <a:ln/>
+        </p:spPr>
+        <p:txBody>
+          <a:bodyPr wrap="square" lIns="0" tIns="0" rIns="0" bIns="0" rtlCol="0" anchor="ctr"/>
+          <a:lstStyle/>
+          <a:p>
+            <a:pPr algn="l" indent="0" marL="0">
+              <a:buNone/>
+            </a:pPr>
+            <a:r>
+              <a:rPr lang="en-US" sz="740" dirty="0">
+                <a:solidFill>
+                  <a:srgbClr val="52514E"/>
+                </a:solidFill>
+                <a:latin typeface="Arial" pitchFamily="34" charset="0"/>
+                <a:ea typeface="Arial" pitchFamily="34" charset="-122"/>
+                <a:cs typeface="Arial" pitchFamily="34" charset="-120"/>
+              </a:rPr>
+              <a:t>Nacidos mar–nov 2010: en gestación el 27-F. Primera entrevista en 2012.</a:t>
+            </a:r>
+            <a:endParaRPr lang="en-US" sz="740" dirty="0"/>
+          </a:p>
+        </p:txBody>
+      </p:sp>
+      <p:sp>
+        <p:nvSpPr>
+          <p:cNvPr id="32" name="Shape 30"/>
+          <p:cNvSpPr/>
+          <p:nvPr/>
+        </p:nvSpPr>
+        <p:spPr>
+          <a:xfrm>
+            <a:off x="5554248" y="2345436"/>
+            <a:ext cx="228600" cy="228600"/>
+          </a:xfrm>
+          <a:prstGeom prst="ellipse">
+            <a:avLst/>
+          </a:prstGeom>
+          <a:solidFill>
+            <a:srgbClr val="2A78D6"/>
+          </a:solidFill>
+          <a:ln w="19050">
+            <a:solidFill>
+              <a:srgbClr val="FFFFFF"/>
+            </a:solidFill>
+            <a:prstDash val="solid"/>
+          </a:ln>
+        </p:spPr>
+      </p:sp>
+      <p:sp>
+        <p:nvSpPr>
+          <p:cNvPr id="33" name="Text 31"/>
+          <p:cNvSpPr txBox="1"/>
+          <p:nvPr/>
+        </p:nvSpPr>
+        <p:spPr>
+          <a:xfrm>
+            <a:off x="5165628" y="2093976"/>
+            <a:ext cx="1005840" cy="155448"/>
+          </a:xfrm>
+          <a:prstGeom prst="rect">
+            <a:avLst/>
+          </a:prstGeom>
+          <a:noFill/>
+          <a:ln/>
+        </p:spPr>
+        <p:txBody>
+          <a:bodyPr wrap="square" lIns="0" tIns="0" rIns="0" bIns="0" rtlCol="0" anchor="ctr"/>
+          <a:lstStyle/>
+          <a:p>
+            <a:pPr algn="ctr" indent="0" marL="0">
+              <a:buNone/>
+            </a:pPr>
+            <a:r>
+              <a:rPr lang="en-US" sz="900" b="1" dirty="0">
+                <a:solidFill>
+                  <a:srgbClr val="1E3D5C"/>
+                </a:solidFill>
+                <a:latin typeface="Arial" pitchFamily="34" charset="0"/>
+                <a:ea typeface="Arial" pitchFamily="34" charset="-122"/>
+                <a:cs typeface="Arial" pitchFamily="34" charset="-120"/>
+              </a:rPr>
+              <a:t>1–2</a:t>
+            </a:r>
+            <a:endParaRPr lang="en-US" sz="900" dirty="0"/>
+          </a:p>
+        </p:txBody>
+      </p:sp>
+      <p:sp>
+        <p:nvSpPr>
+          <p:cNvPr id="34" name="Text 32"/>
+          <p:cNvSpPr txBox="1"/>
+          <p:nvPr/>
+        </p:nvSpPr>
+        <p:spPr>
+          <a:xfrm>
+            <a:off x="4891308" y="2606040"/>
+            <a:ext cx="1554480" cy="146304"/>
+          </a:xfrm>
+          <a:prstGeom prst="rect">
+            <a:avLst/>
+          </a:prstGeom>
+          <a:noFill/>
+          <a:ln/>
+        </p:spPr>
+        <p:txBody>
+          <a:bodyPr wrap="square" lIns="0" tIns="0" rIns="0" bIns="0" rtlCol="0" anchor="ctr"/>
+          <a:lstStyle/>
+          <a:p>
+            <a:pPr algn="ctr" indent="0" marL="0">
+              <a:buNone/>
+            </a:pPr>
+            <a:r>
+              <a:rPr lang="en-US" sz="720" i="1" dirty="0">
+                <a:solidFill>
+                  <a:srgbClr val="898781"/>
+                </a:solidFill>
+                <a:latin typeface="Arial" pitchFamily="34" charset="0"/>
+                <a:ea typeface="Arial" pitchFamily="34" charset="-122"/>
+                <a:cs typeface="Arial" pitchFamily="34" charset="-120"/>
+              </a:rPr>
+              <a:t>entra · corto</a:t>
+            </a:r>
+            <a:endParaRPr lang="en-US" sz="720" dirty="0"/>
+          </a:p>
+        </p:txBody>
+      </p:sp>
+      <p:sp>
+        <p:nvSpPr>
+          <p:cNvPr id="35" name="Shape 33"/>
+          <p:cNvSpPr/>
+          <p:nvPr/>
+        </p:nvSpPr>
+        <p:spPr>
+          <a:xfrm>
+            <a:off x="7911114" y="2345436"/>
+            <a:ext cx="228600" cy="228600"/>
+          </a:xfrm>
+          <a:prstGeom prst="ellipse">
+            <a:avLst/>
+          </a:prstGeom>
+          <a:solidFill>
+            <a:srgbClr val="2A78D6"/>
+          </a:solidFill>
+          <a:ln w="19050">
+            <a:solidFill>
+              <a:srgbClr val="FFFFFF"/>
+            </a:solidFill>
+            <a:prstDash val="solid"/>
+          </a:ln>
+        </p:spPr>
+      </p:sp>
+      <p:sp>
+        <p:nvSpPr>
+          <p:cNvPr id="36" name="Text 34"/>
+          <p:cNvSpPr txBox="1"/>
+          <p:nvPr/>
+        </p:nvSpPr>
+        <p:spPr>
+          <a:xfrm>
+            <a:off x="7522494" y="2093976"/>
+            <a:ext cx="1005840" cy="155448"/>
+          </a:xfrm>
+          <a:prstGeom prst="rect">
+            <a:avLst/>
+          </a:prstGeom>
+          <a:noFill/>
+          <a:ln/>
+        </p:spPr>
+        <p:txBody>
+          <a:bodyPr wrap="square" lIns="0" tIns="0" rIns="0" bIns="0" rtlCol="0" anchor="ctr"/>
+          <a:lstStyle/>
+          <a:p>
+            <a:pPr algn="ctr" indent="0" marL="0">
+              <a:buNone/>
+            </a:pPr>
+            <a:r>
+              <a:rPr lang="en-US" sz="900" b="1" dirty="0">
+                <a:solidFill>
+                  <a:srgbClr val="1E3D5C"/>
+                </a:solidFill>
+                <a:latin typeface="Arial" pitchFamily="34" charset="0"/>
+                <a:ea typeface="Arial" pitchFamily="34" charset="-122"/>
+                <a:cs typeface="Arial" pitchFamily="34" charset="-120"/>
+              </a:rPr>
+              <a:t>6–7</a:t>
+            </a:r>
+            <a:endParaRPr lang="en-US" sz="900" dirty="0"/>
+          </a:p>
+        </p:txBody>
+      </p:sp>
+      <p:sp>
+        <p:nvSpPr>
+          <p:cNvPr id="37" name="Text 35"/>
+          <p:cNvSpPr txBox="1"/>
+          <p:nvPr/>
+        </p:nvSpPr>
+        <p:spPr>
+          <a:xfrm>
+            <a:off x="7248174" y="2606040"/>
+            <a:ext cx="1554480" cy="146304"/>
+          </a:xfrm>
+          <a:prstGeom prst="rect">
+            <a:avLst/>
+          </a:prstGeom>
+          <a:noFill/>
+          <a:ln/>
+        </p:spPr>
+        <p:txBody>
+          <a:bodyPr wrap="square" lIns="0" tIns="0" rIns="0" bIns="0" rtlCol="0" anchor="ctr"/>
+          <a:lstStyle/>
+          <a:p>
+            <a:pPr algn="ctr" indent="0" marL="0">
+              <a:buNone/>
+            </a:pPr>
+            <a:r>
+              <a:rPr lang="en-US" sz="720" i="1" dirty="0">
+                <a:solidFill>
+                  <a:srgbClr val="898781"/>
+                </a:solidFill>
+                <a:latin typeface="Arial" pitchFamily="34" charset="0"/>
+                <a:ea typeface="Arial" pitchFamily="34" charset="-122"/>
+                <a:cs typeface="Arial" pitchFamily="34" charset="-120"/>
+              </a:rPr>
+              <a:t>mediano</a:t>
+            </a:r>
+            <a:endParaRPr lang="en-US" sz="720" dirty="0"/>
+          </a:p>
+        </p:txBody>
+      </p:sp>
+      <p:sp>
+        <p:nvSpPr>
+          <p:cNvPr id="38" name="Text 36"/>
+          <p:cNvSpPr txBox="1"/>
+          <p:nvPr/>
+        </p:nvSpPr>
+        <p:spPr>
+          <a:xfrm>
+            <a:off x="11113298" y="2304288"/>
+            <a:ext cx="329184" cy="292608"/>
+          </a:xfrm>
+          <a:prstGeom prst="rect">
+            <a:avLst/>
+          </a:prstGeom>
+          <a:noFill/>
+          <a:ln/>
+        </p:spPr>
+        <p:txBody>
+          <a:bodyPr wrap="square" lIns="0" tIns="0" rIns="0" bIns="0" rtlCol="0" anchor="ctr"/>
+          <a:lstStyle/>
+          <a:p>
+            <a:pPr algn="ctr" indent="0" marL="0">
+              <a:buNone/>
+            </a:pPr>
+            <a:r>
+              <a:rPr lang="en-US" sz="1400" b="1" dirty="0">
+                <a:solidFill>
+                  <a:srgbClr val="C0392B"/>
+                </a:solidFill>
+                <a:latin typeface="Arial" pitchFamily="34" charset="0"/>
+                <a:ea typeface="Arial" pitchFamily="34" charset="-122"/>
+                <a:cs typeface="Arial" pitchFamily="34" charset="-120"/>
+              </a:rPr>
+              <a:t>✕</a:t>
+            </a:r>
+            <a:endParaRPr lang="en-US" sz="1400" dirty="0"/>
+          </a:p>
+        </p:txBody>
+      </p:sp>
+      <p:sp>
+        <p:nvSpPr>
+          <p:cNvPr id="39" name="Shape 37"/>
+          <p:cNvSpPr/>
+          <p:nvPr/>
+        </p:nvSpPr>
+        <p:spPr>
+          <a:xfrm>
+            <a:off x="5008626" y="3035808"/>
+            <a:ext cx="6649974" cy="256032"/>
+          </a:xfrm>
+          <a:prstGeom prst="roundRect">
+            <a:avLst>
+              <a:gd name="adj" fmla="val 25000"/>
             </a:avLst>
           </a:prstGeom>
           <a:solidFill>
@@ -9109,69 +9623,69 @@
       </p:sp>
       <p:sp>
         <p:nvSpPr>
-          <p:cNvPr id="25" name="Text 23"/>
-          <p:cNvSpPr txBox="1"/>
-          <p:nvPr/>
-        </p:nvSpPr>
-        <p:spPr>
-          <a:xfrm>
-            <a:off x="457200" y="2788920"/>
-            <a:ext cx="2103120" cy="182880"/>
-          </a:xfrm>
-          <a:prstGeom prst="rect">
-            <a:avLst/>
-          </a:prstGeom>
-          <a:noFill/>
-          <a:ln/>
-        </p:spPr>
-        <p:txBody>
-          <a:bodyPr wrap="square" lIns="0" tIns="0" rIns="0" bIns="0" rtlCol="0" anchor="ctr"/>
-          <a:lstStyle/>
-          <a:p>
-            <a:pPr algn="l" indent="0" marL="0">
-              <a:buNone/>
-            </a:pPr>
-            <a:r>
-              <a:rPr lang="en-US" sz="950" b="1" dirty="0">
-                <a:solidFill>
-                  <a:srgbClr val="0B0B0B"/>
-                </a:solidFill>
-                <a:latin typeface="Arial" pitchFamily="34" charset="0"/>
-                <a:ea typeface="Arial" pitchFamily="34" charset="-122"/>
-                <a:cs typeface="Arial" pitchFamily="34" charset="-120"/>
-              </a:rPr>
-              <a:t>AFFECTED = 0</a:t>
-            </a:r>
-            <a:endParaRPr lang="en-US" sz="950" dirty="0"/>
-          </a:p>
-        </p:txBody>
-      </p:sp>
-      <p:sp>
-        <p:nvSpPr>
-          <p:cNvPr id="26" name="Text 24"/>
-          <p:cNvSpPr txBox="1"/>
-          <p:nvPr/>
-        </p:nvSpPr>
-        <p:spPr>
-          <a:xfrm>
-            <a:off x="457200" y="2980944"/>
-            <a:ext cx="2103120" cy="384048"/>
-          </a:xfrm>
-          <a:prstGeom prst="rect">
-            <a:avLst/>
-          </a:prstGeom>
-          <a:noFill/>
-          <a:ln/>
-        </p:spPr>
-        <p:txBody>
-          <a:bodyPr wrap="square" lIns="0" tIns="0" rIns="0" bIns="0" rtlCol="0" anchor="ctr"/>
-          <a:lstStyle/>
-          <a:p>
-            <a:pPr algn="l" indent="0" marL="0">
-              <a:buNone/>
-            </a:pPr>
-            <a:r>
-              <a:rPr lang="en-US" sz="800" dirty="0">
+          <p:cNvPr id="40" name="Text 38"/>
+          <p:cNvSpPr txBox="1"/>
+          <p:nvPr/>
+        </p:nvSpPr>
+        <p:spPr>
+          <a:xfrm>
+            <a:off x="457200" y="2916936"/>
+            <a:ext cx="2121408" cy="155448"/>
+          </a:xfrm>
+          <a:prstGeom prst="rect">
+            <a:avLst/>
+          </a:prstGeom>
+          <a:noFill/>
+          <a:ln/>
+        </p:spPr>
+        <p:txBody>
+          <a:bodyPr wrap="square" lIns="0" tIns="0" rIns="0" bIns="0" rtlCol="0" anchor="ctr"/>
+          <a:lstStyle/>
+          <a:p>
+            <a:pPr algn="l" indent="0" marL="0">
+              <a:buNone/>
+            </a:pPr>
+            <a:r>
+              <a:rPr lang="en-US" sz="860" b="1" dirty="0">
+                <a:solidFill>
+                  <a:srgbClr val="0E7A54"/>
+                </a:solidFill>
+                <a:latin typeface="Arial" pitchFamily="34" charset="0"/>
+                <a:ea typeface="Arial" pitchFamily="34" charset="-122"/>
+                <a:cs typeface="Arial" pitchFamily="34" charset="-120"/>
+              </a:rPr>
+              <a:t>AFFECTED = 0 · refresco 2012</a:t>
+            </a:r>
+            <a:endParaRPr lang="en-US" sz="860" dirty="0"/>
+          </a:p>
+        </p:txBody>
+      </p:sp>
+      <p:sp>
+        <p:nvSpPr>
+          <p:cNvPr id="41" name="Text 39"/>
+          <p:cNvSpPr txBox="1"/>
+          <p:nvPr/>
+        </p:nvSpPr>
+        <p:spPr>
+          <a:xfrm>
+            <a:off x="457200" y="3081528"/>
+            <a:ext cx="2121408" cy="402336"/>
+          </a:xfrm>
+          <a:prstGeom prst="rect">
+            <a:avLst/>
+          </a:prstGeom>
+          <a:noFill/>
+          <a:ln/>
+        </p:spPr>
+        <p:txBody>
+          <a:bodyPr wrap="square" lIns="0" tIns="0" rIns="0" bIns="0" rtlCol="0" anchor="ctr"/>
+          <a:lstStyle/>
+          <a:p>
+            <a:pPr algn="l" indent="0" marL="0">
+              <a:buNone/>
+            </a:pPr>
+            <a:r>
+              <a:rPr lang="en-US" sz="740" dirty="0">
                 <a:solidFill>
                   <a:srgbClr val="52514E"/>
                 </a:solidFill>
@@ -9179,22 +9693,125 @@
                 <a:ea typeface="Arial" pitchFamily="34" charset="-122"/>
                 <a:cs typeface="Arial" pitchFamily="34" charset="-120"/>
               </a:rPr>
-              <a:t>Nacidos 2011 — refresco 2012</a:t>
-            </a:r>
-            <a:endParaRPr lang="en-US" sz="800" dirty="0"/>
-          </a:p>
-        </p:txBody>
-      </p:sp>
-      <p:sp>
-        <p:nvSpPr>
-          <p:cNvPr id="27" name="Shape 25"/>
+              <a:t>Nacidos 2011: concebidos DESPUÉS del 27-F. Primera entrevista en 2012, de bebés.</a:t>
+            </a:r>
+            <a:endParaRPr lang="en-US" sz="740" dirty="0"/>
+          </a:p>
+        </p:txBody>
+      </p:sp>
+      <p:sp>
+        <p:nvSpPr>
+          <p:cNvPr id="42" name="Shape 40"/>
           <p:cNvSpPr/>
           <p:nvPr/>
         </p:nvSpPr>
         <p:spPr>
           <a:xfrm>
-            <a:off x="7897398" y="2935224"/>
-            <a:ext cx="256032" cy="256032"/>
+            <a:off x="5586252" y="3081528"/>
+            <a:ext cx="164592" cy="164592"/>
+          </a:xfrm>
+          <a:prstGeom prst="ellipse">
+            <a:avLst/>
+          </a:prstGeom>
+          <a:solidFill>
+            <a:srgbClr val="FFFFFF"/>
+          </a:solidFill>
+          <a:ln w="22225">
+            <a:solidFill>
+              <a:srgbClr val="1BAF7A"/>
+            </a:solidFill>
+            <a:prstDash val="solid"/>
+          </a:ln>
+        </p:spPr>
+      </p:sp>
+      <p:sp>
+        <p:nvSpPr>
+          <p:cNvPr id="43" name="Text 41"/>
+          <p:cNvSpPr txBox="1"/>
+          <p:nvPr/>
+        </p:nvSpPr>
+        <p:spPr>
+          <a:xfrm>
+            <a:off x="5165628" y="2798064"/>
+            <a:ext cx="1005840" cy="155448"/>
+          </a:xfrm>
+          <a:prstGeom prst="rect">
+            <a:avLst/>
+          </a:prstGeom>
+          <a:noFill/>
+          <a:ln/>
+        </p:spPr>
+        <p:txBody>
+          <a:bodyPr wrap="square" lIns="0" tIns="0" rIns="0" bIns="0" rtlCol="0" anchor="ctr"/>
+          <a:lstStyle/>
+          <a:p>
+            <a:pPr algn="ctr" indent="0" marL="0">
+              <a:buNone/>
+            </a:pPr>
+            <a:r>
+              <a:rPr lang="en-US" sz="900" b="1" dirty="0">
+                <a:solidFill>
+                  <a:srgbClr val="0E7A54"/>
+                </a:solidFill>
+                <a:latin typeface="Arial" pitchFamily="34" charset="0"/>
+                <a:ea typeface="Arial" pitchFamily="34" charset="-122"/>
+                <a:cs typeface="Arial" pitchFamily="34" charset="-120"/>
+              </a:rPr>
+              <a:t>0–1</a:t>
+            </a:r>
+            <a:endParaRPr lang="en-US" sz="900" dirty="0"/>
+          </a:p>
+        </p:txBody>
+      </p:sp>
+      <p:sp>
+        <p:nvSpPr>
+          <p:cNvPr id="44" name="Text 42"/>
+          <p:cNvSpPr txBox="1"/>
+          <p:nvPr/>
+        </p:nvSpPr>
+        <p:spPr>
+          <a:xfrm>
+            <a:off x="4891308" y="3310128"/>
+            <a:ext cx="1554480" cy="146304"/>
+          </a:xfrm>
+          <a:prstGeom prst="rect">
+            <a:avLst/>
+          </a:prstGeom>
+          <a:noFill/>
+          <a:ln/>
+        </p:spPr>
+        <p:txBody>
+          <a:bodyPr wrap="square" lIns="0" tIns="0" rIns="0" bIns="0" rtlCol="0" anchor="ctr"/>
+          <a:lstStyle/>
+          <a:p>
+            <a:pPr algn="ctr" indent="0" marL="0">
+              <a:buNone/>
+            </a:pPr>
+            <a:r>
+              <a:rPr lang="en-US" sz="720" i="1" dirty="0">
+                <a:solidFill>
+                  <a:srgbClr val="898781"/>
+                </a:solidFill>
+                <a:latin typeface="Arial" pitchFamily="34" charset="0"/>
+                <a:ea typeface="Arial" pitchFamily="34" charset="-122"/>
+                <a:cs typeface="Arial" pitchFamily="34" charset="-120"/>
+              </a:rPr>
+              <a:t>entra (sin tests: bebés)</a:t>
+            </a:r>
+            <a:endParaRPr lang="en-US" sz="720" dirty="0"/>
+          </a:p>
+        </p:txBody>
+      </p:sp>
+      <p:sp>
+        <p:nvSpPr>
+          <p:cNvPr id="45" name="Shape 43"/>
+          <p:cNvSpPr/>
+          <p:nvPr/>
+        </p:nvSpPr>
+        <p:spPr>
+          <a:xfrm>
+            <a:off x="7911114" y="3049524"/>
+            <a:ext cx="228600" cy="228600"/>
           </a:xfrm>
           <a:prstGeom prst="ellipse">
             <a:avLst/>
@@ -9212,14 +9829,14 @@
       </p:sp>
       <p:sp>
         <p:nvSpPr>
-          <p:cNvPr id="28" name="Text 26"/>
-          <p:cNvSpPr txBox="1"/>
-          <p:nvPr/>
-        </p:nvSpPr>
-        <p:spPr>
-          <a:xfrm>
-            <a:off x="7522494" y="2633472"/>
-            <a:ext cx="1005840" cy="182880"/>
+          <p:cNvPr id="46" name="Text 44"/>
+          <p:cNvSpPr txBox="1"/>
+          <p:nvPr/>
+        </p:nvSpPr>
+        <p:spPr>
+          <a:xfrm>
+            <a:off x="7522494" y="2798064"/>
+            <a:ext cx="1005840" cy="155448"/>
           </a:xfrm>
           <a:prstGeom prst="rect">
             <a:avLst/>
@@ -9235,7 +9852,7 @@
               <a:buNone/>
             </a:pPr>
             <a:r>
-              <a:rPr lang="en-US" sz="1000" b="1" dirty="0">
+              <a:rPr lang="en-US" sz="900" b="1" dirty="0">
                 <a:solidFill>
                   <a:srgbClr val="0E7A54"/>
                 </a:solidFill>
@@ -9245,20 +9862,20 @@
               </a:rPr>
               <a:t>5–6</a:t>
             </a:r>
-            <a:endParaRPr lang="en-US" sz="1000" dirty="0"/>
-          </a:p>
-        </p:txBody>
-      </p:sp>
-      <p:sp>
-        <p:nvSpPr>
-          <p:cNvPr id="29" name="Text 27"/>
-          <p:cNvSpPr txBox="1"/>
-          <p:nvPr/>
-        </p:nvSpPr>
-        <p:spPr>
-          <a:xfrm>
-            <a:off x="7476774" y="3246120"/>
-            <a:ext cx="1097280" cy="164592"/>
+            <a:endParaRPr lang="en-US" sz="900" dirty="0"/>
+          </a:p>
+        </p:txBody>
+      </p:sp>
+      <p:sp>
+        <p:nvSpPr>
+          <p:cNvPr id="47" name="Text 45"/>
+          <p:cNvSpPr txBox="1"/>
+          <p:nvPr/>
+        </p:nvSpPr>
+        <p:spPr>
+          <a:xfrm>
+            <a:off x="7248174" y="3310128"/>
+            <a:ext cx="1554480" cy="146304"/>
           </a:xfrm>
           <a:prstGeom prst="rect">
             <a:avLst/>
@@ -9274,7 +9891,7 @@
               <a:buNone/>
             </a:pPr>
             <a:r>
-              <a:rPr lang="en-US" sz="800" dirty="0">
+              <a:rPr lang="en-US" sz="720" i="1" dirty="0">
                 <a:solidFill>
                   <a:srgbClr val="898781"/>
                 </a:solidFill>
@@ -9284,24 +9901,63 @@
               </a:rPr>
               <a:t>control</a:t>
             </a:r>
-            <a:endParaRPr lang="en-US" sz="800" dirty="0"/>
-          </a:p>
-        </p:txBody>
-      </p:sp>
-      <p:sp>
-        <p:nvSpPr>
-          <p:cNvPr id="30" name="Shape 28"/>
+            <a:endParaRPr lang="en-US" sz="720" dirty="0"/>
+          </a:p>
+        </p:txBody>
+      </p:sp>
+      <p:sp>
+        <p:nvSpPr>
+          <p:cNvPr id="48" name="Text 46"/>
+          <p:cNvSpPr txBox="1"/>
+          <p:nvPr/>
+        </p:nvSpPr>
+        <p:spPr>
+          <a:xfrm>
+            <a:off x="11113298" y="3008376"/>
+            <a:ext cx="329184" cy="292608"/>
+          </a:xfrm>
+          <a:prstGeom prst="rect">
+            <a:avLst/>
+          </a:prstGeom>
+          <a:noFill/>
+          <a:ln/>
+        </p:spPr>
+        <p:txBody>
+          <a:bodyPr wrap="square" lIns="0" tIns="0" rIns="0" bIns="0" rtlCol="0" anchor="ctr"/>
+          <a:lstStyle/>
+          <a:p>
+            <a:pPr algn="ctr" indent="0" marL="0">
+              <a:buNone/>
+            </a:pPr>
+            <a:r>
+              <a:rPr lang="en-US" sz="1400" b="1" dirty="0">
+                <a:solidFill>
+                  <a:srgbClr val="C0392B"/>
+                </a:solidFill>
+                <a:latin typeface="Arial" pitchFamily="34" charset="0"/>
+                <a:ea typeface="Arial" pitchFamily="34" charset="-122"/>
+                <a:cs typeface="Arial" pitchFamily="34" charset="-120"/>
+              </a:rPr>
+              <a:t>✕</a:t>
+            </a:r>
+            <a:endParaRPr lang="en-US" sz="1400" dirty="0"/>
+          </a:p>
+        </p:txBody>
+      </p:sp>
+      <p:sp>
+        <p:nvSpPr>
+          <p:cNvPr id="49" name="Shape 47"/>
           <p:cNvSpPr/>
           <p:nvPr/>
         </p:nvSpPr>
         <p:spPr>
           <a:xfrm>
-            <a:off x="5479999" y="3749040"/>
-            <a:ext cx="6178601" cy="274320"/>
+            <a:off x="5479999" y="3739896"/>
+            <a:ext cx="6178601" cy="256032"/>
           </a:xfrm>
           <a:prstGeom prst="roundRect">
             <a:avLst>
-              <a:gd name="adj" fmla="val 26667"/>
+              <a:gd name="adj" fmla="val 25000"/>
             </a:avLst>
           </a:prstGeom>
           <a:solidFill>
@@ -9317,69 +9973,69 @@
       </p:sp>
       <p:sp>
         <p:nvSpPr>
-          <p:cNvPr id="31" name="Text 29"/>
-          <p:cNvSpPr txBox="1"/>
-          <p:nvPr/>
-        </p:nvSpPr>
-        <p:spPr>
-          <a:xfrm>
-            <a:off x="457200" y="3611880"/>
-            <a:ext cx="2103120" cy="182880"/>
-          </a:xfrm>
-          <a:prstGeom prst="rect">
-            <a:avLst/>
-          </a:prstGeom>
-          <a:noFill/>
-          <a:ln/>
-        </p:spPr>
-        <p:txBody>
-          <a:bodyPr wrap="square" lIns="0" tIns="0" rIns="0" bIns="0" rtlCol="0" anchor="ctr"/>
-          <a:lstStyle/>
-          <a:p>
-            <a:pPr algn="l" indent="0" marL="0">
-              <a:buNone/>
-            </a:pPr>
-            <a:r>
-              <a:rPr lang="en-US" sz="950" b="1" dirty="0">
-                <a:solidFill>
-                  <a:srgbClr val="0B0B0B"/>
-                </a:solidFill>
-                <a:latin typeface="Arial" pitchFamily="34" charset="0"/>
-                <a:ea typeface="Arial" pitchFamily="34" charset="-122"/>
-                <a:cs typeface="Arial" pitchFamily="34" charset="-120"/>
-              </a:rPr>
-              <a:t>AFFECTED = 0</a:t>
-            </a:r>
-            <a:endParaRPr lang="en-US" sz="950" dirty="0"/>
-          </a:p>
-        </p:txBody>
-      </p:sp>
-      <p:sp>
-        <p:nvSpPr>
-          <p:cNvPr id="32" name="Text 30"/>
-          <p:cNvSpPr txBox="1"/>
-          <p:nvPr/>
-        </p:nvSpPr>
-        <p:spPr>
-          <a:xfrm>
-            <a:off x="457200" y="3803904"/>
-            <a:ext cx="2103120" cy="384048"/>
-          </a:xfrm>
-          <a:prstGeom prst="rect">
-            <a:avLst/>
-          </a:prstGeom>
-          <a:noFill/>
-          <a:ln/>
-        </p:spPr>
-        <p:txBody>
-          <a:bodyPr wrap="square" lIns="0" tIns="0" rIns="0" bIns="0" rtlCol="0" anchor="ctr"/>
-          <a:lstStyle/>
-          <a:p>
-            <a:pPr algn="l" indent="0" marL="0">
-              <a:buNone/>
-            </a:pPr>
-            <a:r>
-              <a:rPr lang="en-US" sz="800" dirty="0">
+          <p:cNvPr id="50" name="Text 48"/>
+          <p:cNvSpPr txBox="1"/>
+          <p:nvPr/>
+        </p:nvSpPr>
+        <p:spPr>
+          <a:xfrm>
+            <a:off x="457200" y="3621024"/>
+            <a:ext cx="2121408" cy="155448"/>
+          </a:xfrm>
+          <a:prstGeom prst="rect">
+            <a:avLst/>
+          </a:prstGeom>
+          <a:noFill/>
+          <a:ln/>
+        </p:spPr>
+        <p:txBody>
+          <a:bodyPr wrap="square" lIns="0" tIns="0" rIns="0" bIns="0" rtlCol="0" anchor="ctr"/>
+          <a:lstStyle/>
+          <a:p>
+            <a:pPr algn="l" indent="0" marL="0">
+              <a:buNone/>
+            </a:pPr>
+            <a:r>
+              <a:rPr lang="en-US" sz="860" b="1" dirty="0">
+                <a:solidFill>
+                  <a:srgbClr val="0E7A54"/>
+                </a:solidFill>
+                <a:latin typeface="Arial" pitchFamily="34" charset="0"/>
+                <a:ea typeface="Arial" pitchFamily="34" charset="-122"/>
+                <a:cs typeface="Arial" pitchFamily="34" charset="-120"/>
+              </a:rPr>
+              <a:t>AFFECTED = 0 · refresco 2017</a:t>
+            </a:r>
+            <a:endParaRPr lang="en-US" sz="860" dirty="0"/>
+          </a:p>
+        </p:txBody>
+      </p:sp>
+      <p:sp>
+        <p:nvSpPr>
+          <p:cNvPr id="51" name="Text 49"/>
+          <p:cNvSpPr txBox="1"/>
+          <p:nvPr/>
+        </p:nvSpPr>
+        <p:spPr>
+          <a:xfrm>
+            <a:off x="457200" y="3785616"/>
+            <a:ext cx="2121408" cy="402336"/>
+          </a:xfrm>
+          <a:prstGeom prst="rect">
+            <a:avLst/>
+          </a:prstGeom>
+          <a:noFill/>
+          <a:ln/>
+        </p:spPr>
+        <p:txBody>
+          <a:bodyPr wrap="square" lIns="0" tIns="0" rIns="0" bIns="0" rtlCol="0" anchor="ctr"/>
+          <a:lstStyle/>
+          <a:p>
+            <a:pPr algn="l" indent="0" marL="0">
+              <a:buNone/>
+            </a:pPr>
+            <a:r>
+              <a:rPr lang="en-US" sz="740" dirty="0">
                 <a:solidFill>
                   <a:srgbClr val="52514E"/>
                 </a:solidFill>
@@ -9387,22 +10043,22 @@
                 <a:ea typeface="Arial" pitchFamily="34" charset="-122"/>
                 <a:cs typeface="Arial" pitchFamily="34" charset="-120"/>
               </a:rPr>
-              <a:t>Nacidos 2012–2015 — refresco 2017</a:t>
-            </a:r>
-            <a:endParaRPr lang="en-US" sz="800" dirty="0"/>
-          </a:p>
-        </p:txBody>
-      </p:sp>
-      <p:sp>
-        <p:nvSpPr>
-          <p:cNvPr id="33" name="Shape 31"/>
+              <a:t>Nacidos 2012–2015. Primera (y única) entrevista en 2017.</a:t>
+            </a:r>
+            <a:endParaRPr lang="en-US" sz="740" dirty="0"/>
+          </a:p>
+        </p:txBody>
+      </p:sp>
+      <p:sp>
+        <p:nvSpPr>
+          <p:cNvPr id="52" name="Shape 50"/>
           <p:cNvSpPr/>
           <p:nvPr/>
         </p:nvSpPr>
         <p:spPr>
           <a:xfrm>
-            <a:off x="7897398" y="3758184"/>
-            <a:ext cx="256032" cy="256032"/>
+            <a:off x="7911114" y="3753612"/>
+            <a:ext cx="228600" cy="228600"/>
           </a:xfrm>
           <a:prstGeom prst="ellipse">
             <a:avLst/>
@@ -9420,14 +10076,14 @@
       </p:sp>
       <p:sp>
         <p:nvSpPr>
-          <p:cNvPr id="34" name="Text 32"/>
-          <p:cNvSpPr txBox="1"/>
-          <p:nvPr/>
-        </p:nvSpPr>
-        <p:spPr>
-          <a:xfrm>
-            <a:off x="7522494" y="3456432"/>
-            <a:ext cx="1005840" cy="182880"/>
+          <p:cNvPr id="53" name="Text 51"/>
+          <p:cNvSpPr txBox="1"/>
+          <p:nvPr/>
+        </p:nvSpPr>
+        <p:spPr>
+          <a:xfrm>
+            <a:off x="7522494" y="3502152"/>
+            <a:ext cx="1005840" cy="155448"/>
           </a:xfrm>
           <a:prstGeom prst="rect">
             <a:avLst/>
@@ -9443,7 +10099,7 @@
               <a:buNone/>
             </a:pPr>
             <a:r>
-              <a:rPr lang="en-US" sz="1000" b="1" dirty="0">
+              <a:rPr lang="en-US" sz="900" b="1" dirty="0">
                 <a:solidFill>
                   <a:srgbClr val="0E7A54"/>
                 </a:solidFill>
@@ -9453,20 +10109,20 @@
               </a:rPr>
               <a:t>2–5</a:t>
             </a:r>
-            <a:endParaRPr lang="en-US" sz="1000" dirty="0"/>
-          </a:p>
-        </p:txBody>
-      </p:sp>
-      <p:sp>
-        <p:nvSpPr>
-          <p:cNvPr id="35" name="Text 33"/>
-          <p:cNvSpPr txBox="1"/>
-          <p:nvPr/>
-        </p:nvSpPr>
-        <p:spPr>
-          <a:xfrm>
-            <a:off x="7476774" y="4069080"/>
-            <a:ext cx="1097280" cy="164592"/>
+            <a:endParaRPr lang="en-US" sz="900" dirty="0"/>
+          </a:p>
+        </p:txBody>
+      </p:sp>
+      <p:sp>
+        <p:nvSpPr>
+          <p:cNvPr id="54" name="Text 52"/>
+          <p:cNvSpPr txBox="1"/>
+          <p:nvPr/>
+        </p:nvSpPr>
+        <p:spPr>
+          <a:xfrm>
+            <a:off x="7248174" y="4014216"/>
+            <a:ext cx="1554480" cy="146304"/>
           </a:xfrm>
           <a:prstGeom prst="rect">
             <a:avLst/>
@@ -9482,7 +10138,7 @@
               <a:buNone/>
             </a:pPr>
             <a:r>
-              <a:rPr lang="en-US" sz="800" dirty="0">
+              <a:rPr lang="en-US" sz="720" i="1" dirty="0">
                 <a:solidFill>
                   <a:srgbClr val="898781"/>
                 </a:solidFill>
@@ -9490,7 +10146,127 @@
                 <a:ea typeface="Arial" pitchFamily="34" charset="-122"/>
                 <a:cs typeface="Arial" pitchFamily="34" charset="-120"/>
               </a:rPr>
-              <a:t>control</a:t>
+              <a:t>entra · control</a:t>
+            </a:r>
+            <a:endParaRPr lang="en-US" sz="720" dirty="0"/>
+          </a:p>
+        </p:txBody>
+      </p:sp>
+      <p:sp>
+        <p:nvSpPr>
+          <p:cNvPr id="55" name="Text 53"/>
+          <p:cNvSpPr txBox="1"/>
+          <p:nvPr/>
+        </p:nvSpPr>
+        <p:spPr>
+          <a:xfrm>
+            <a:off x="11113298" y="3712464"/>
+            <a:ext cx="329184" cy="292608"/>
+          </a:xfrm>
+          <a:prstGeom prst="rect">
+            <a:avLst/>
+          </a:prstGeom>
+          <a:noFill/>
+          <a:ln/>
+        </p:spPr>
+        <p:txBody>
+          <a:bodyPr wrap="square" lIns="0" tIns="0" rIns="0" bIns="0" rtlCol="0" anchor="ctr"/>
+          <a:lstStyle/>
+          <a:p>
+            <a:pPr algn="ctr" indent="0" marL="0">
+              <a:buNone/>
+            </a:pPr>
+            <a:r>
+              <a:rPr lang="en-US" sz="1400" b="1" dirty="0">
+                <a:solidFill>
+                  <a:srgbClr val="C0392B"/>
+                </a:solidFill>
+                <a:latin typeface="Arial" pitchFamily="34" charset="0"/>
+                <a:ea typeface="Arial" pitchFamily="34" charset="-122"/>
+                <a:cs typeface="Arial" pitchFamily="34" charset="-120"/>
+              </a:rPr>
+              <a:t>✕</a:t>
+            </a:r>
+            <a:endParaRPr lang="en-US" sz="1400" dirty="0"/>
+          </a:p>
+        </p:txBody>
+      </p:sp>
+      <p:sp>
+        <p:nvSpPr>
+          <p:cNvPr id="56" name="Text 54"/>
+          <p:cNvSpPr txBox="1"/>
+          <p:nvPr/>
+        </p:nvSpPr>
+        <p:spPr>
+          <a:xfrm>
+            <a:off x="10363490" y="4050792"/>
+            <a:ext cx="1828800" cy="164592"/>
+          </a:xfrm>
+          <a:prstGeom prst="rect">
+            <a:avLst/>
+          </a:prstGeom>
+          <a:noFill/>
+          <a:ln/>
+        </p:spPr>
+        <p:txBody>
+          <a:bodyPr wrap="square" lIns="0" tIns="0" rIns="0" bIns="0" rtlCol="0" anchor="ctr"/>
+          <a:lstStyle/>
+          <a:p>
+            <a:pPr algn="ctr" indent="0" marL="0">
+              <a:buNone/>
+            </a:pPr>
+            <a:r>
+              <a:rPr lang="en-US" sz="750" b="1" dirty="0">
+                <a:solidFill>
+                  <a:srgbClr val="C0392B"/>
+                </a:solidFill>
+                <a:latin typeface="Arial" pitchFamily="34" charset="0"/>
+                <a:ea typeface="Arial" pitchFamily="34" charset="-122"/>
+                <a:cs typeface="Arial" pitchFamily="34" charset="-120"/>
+              </a:rPr>
+              <a:t>no re-entrevistados en 2024</a:t>
+            </a:r>
+            <a:endParaRPr lang="en-US" sz="750" dirty="0"/>
+          </a:p>
+        </p:txBody>
+      </p:sp>
+      <p:sp>
+        <p:nvSpPr>
+          <p:cNvPr id="57" name="Text 55"/>
+          <p:cNvSpPr txBox="1"/>
+          <p:nvPr/>
+        </p:nvSpPr>
+        <p:spPr>
+          <a:xfrm>
+            <a:off x="2651760" y="4334256"/>
+            <a:ext cx="9052560" cy="310896"/>
+          </a:xfrm>
+          <a:prstGeom prst="rect">
+            <a:avLst/>
+          </a:prstGeom>
+          <a:noFill/>
+          <a:ln/>
+        </p:spPr>
+        <p:txBody>
+          <a:bodyPr wrap="square" lIns="0" tIns="0" rIns="0" bIns="0" rtlCol="0" anchor="ctr"/>
+          <a:lstStyle/>
+          <a:p>
+            <a:pPr algn="l" indent="0" marL="0">
+              <a:lnSpc>
+                <a:spcPct val="105000"/>
+              </a:lnSpc>
+              <a:buNone/>
+            </a:pPr>
+            <a:r>
+              <a:rPr lang="en-US" sz="800" i="1" dirty="0">
+                <a:solidFill>
+                  <a:srgbClr val="898781"/>
+                </a:solidFill>
+                <a:latin typeface="Arial" pitchFamily="34" charset="0"/>
+                <a:ea typeface="Arial" pitchFamily="34" charset="-122"/>
+                <a:cs typeface="Arial" pitchFamily="34" charset="-120"/>
+              </a:rPr>
+              <a:t>Las barras empiezan al NACER. Anillo = primera entrevista sin test utilizable; punto lleno = test que usa la regresión. Las respuestas de la ola 2010 NO se usan como outcome (solo línea base y test de atrición). Ventana fina: fila 2 vs fila 3, 12 meses aparte (Gillmore C.31: −0,25 DE).</a:t>
             </a:r>
             <a:endParaRPr lang="en-US" sz="800" dirty="0"/>
           </a:p>
@@ -9498,324 +10274,18 @@
       </p:sp>
       <p:sp>
         <p:nvSpPr>
-          <p:cNvPr id="36" name="Text 34"/>
-          <p:cNvSpPr txBox="1"/>
-          <p:nvPr/>
-        </p:nvSpPr>
-        <p:spPr>
-          <a:xfrm>
-            <a:off x="11095010" y="2889504"/>
-            <a:ext cx="365760" cy="329184"/>
-          </a:xfrm>
-          <a:prstGeom prst="rect">
-            <a:avLst/>
-          </a:prstGeom>
-          <a:noFill/>
-          <a:ln/>
-        </p:spPr>
-        <p:txBody>
-          <a:bodyPr wrap="square" lIns="0" tIns="0" rIns="0" bIns="0" rtlCol="0" anchor="ctr"/>
-          <a:lstStyle/>
-          <a:p>
-            <a:pPr algn="ctr" indent="0" marL="0">
-              <a:buNone/>
-            </a:pPr>
-            <a:r>
-              <a:rPr lang="en-US" sz="1600" b="1" dirty="0">
-                <a:solidFill>
-                  <a:srgbClr val="C0392B"/>
-                </a:solidFill>
-                <a:latin typeface="Arial" pitchFamily="34" charset="0"/>
-                <a:ea typeface="Arial" pitchFamily="34" charset="-122"/>
-                <a:cs typeface="Arial" pitchFamily="34" charset="-120"/>
-              </a:rPr>
-              <a:t>✕</a:t>
-            </a:r>
-            <a:endParaRPr lang="en-US" sz="1600" dirty="0"/>
-          </a:p>
-        </p:txBody>
-      </p:sp>
-      <p:sp>
-        <p:nvSpPr>
-          <p:cNvPr id="37" name="Text 35"/>
-          <p:cNvSpPr txBox="1"/>
-          <p:nvPr/>
-        </p:nvSpPr>
-        <p:spPr>
-          <a:xfrm>
-            <a:off x="11095010" y="3712464"/>
-            <a:ext cx="365760" cy="329184"/>
-          </a:xfrm>
-          <a:prstGeom prst="rect">
-            <a:avLst/>
-          </a:prstGeom>
-          <a:noFill/>
-          <a:ln/>
-        </p:spPr>
-        <p:txBody>
-          <a:bodyPr wrap="square" lIns="0" tIns="0" rIns="0" bIns="0" rtlCol="0" anchor="ctr"/>
-          <a:lstStyle/>
-          <a:p>
-            <a:pPr algn="ctr" indent="0" marL="0">
-              <a:buNone/>
-            </a:pPr>
-            <a:r>
-              <a:rPr lang="en-US" sz="1600" b="1" dirty="0">
-                <a:solidFill>
-                  <a:srgbClr val="C0392B"/>
-                </a:solidFill>
-                <a:latin typeface="Arial" pitchFamily="34" charset="0"/>
-                <a:ea typeface="Arial" pitchFamily="34" charset="-122"/>
-                <a:cs typeface="Arial" pitchFamily="34" charset="-120"/>
-              </a:rPr>
-              <a:t>✕</a:t>
-            </a:r>
-            <a:endParaRPr lang="en-US" sz="1600" dirty="0"/>
-          </a:p>
-        </p:txBody>
-      </p:sp>
-      <p:sp>
-        <p:nvSpPr>
-          <p:cNvPr id="38" name="Text 36"/>
-          <p:cNvSpPr txBox="1"/>
-          <p:nvPr/>
-        </p:nvSpPr>
-        <p:spPr>
-          <a:xfrm>
-            <a:off x="10500650" y="4142232"/>
-            <a:ext cx="1554480" cy="182880"/>
-          </a:xfrm>
-          <a:prstGeom prst="rect">
-            <a:avLst/>
-          </a:prstGeom>
-          <a:noFill/>
-          <a:ln/>
-        </p:spPr>
-        <p:txBody>
-          <a:bodyPr wrap="square" lIns="0" tIns="0" rIns="0" bIns="0" rtlCol="0" anchor="ctr"/>
-          <a:lstStyle/>
-          <a:p>
-            <a:pPr algn="ctr" indent="0" marL="0">
-              <a:buNone/>
-            </a:pPr>
-            <a:r>
-              <a:rPr lang="en-US" sz="800" b="1" dirty="0">
-                <a:solidFill>
-                  <a:srgbClr val="C0392B"/>
-                </a:solidFill>
-                <a:latin typeface="Arial" pitchFamily="34" charset="0"/>
-                <a:ea typeface="Arial" pitchFamily="34" charset="-122"/>
-                <a:cs typeface="Arial" pitchFamily="34" charset="-120"/>
-              </a:rPr>
-              <a:t>no re-entrevistados</a:t>
-            </a:r>
-            <a:endParaRPr lang="en-US" sz="800" dirty="0"/>
-          </a:p>
-        </p:txBody>
-      </p:sp>
-      <p:sp>
-        <p:nvSpPr>
-          <p:cNvPr id="39" name="Shape 37"/>
+          <p:cNvPr id="58" name="Shape 56"/>
           <p:cNvSpPr/>
           <p:nvPr/>
         </p:nvSpPr>
         <p:spPr>
           <a:xfrm>
-            <a:off x="5586252" y="2980944"/>
-            <a:ext cx="164592" cy="164592"/>
-          </a:xfrm>
-          <a:prstGeom prst="ellipse">
-            <a:avLst/>
-          </a:prstGeom>
-          <a:solidFill>
-            <a:srgbClr val="FFFFFF"/>
-          </a:solidFill>
-          <a:ln w="22225">
-            <a:solidFill>
-              <a:srgbClr val="0E7A54"/>
-            </a:solidFill>
-            <a:prstDash val="solid"/>
-          </a:ln>
-        </p:spPr>
-      </p:sp>
-      <p:sp>
-        <p:nvSpPr>
-          <p:cNvPr id="40" name="Text 38"/>
-          <p:cNvSpPr txBox="1"/>
-          <p:nvPr/>
-        </p:nvSpPr>
-        <p:spPr>
-          <a:xfrm>
-            <a:off x="4799868" y="3218688"/>
-            <a:ext cx="1737360" cy="164592"/>
-          </a:xfrm>
-          <a:prstGeom prst="rect">
-            <a:avLst/>
-          </a:prstGeom>
-          <a:noFill/>
-          <a:ln/>
-        </p:spPr>
-        <p:txBody>
-          <a:bodyPr wrap="square" lIns="0" tIns="0" rIns="0" bIns="0" rtlCol="0" anchor="ctr"/>
-          <a:lstStyle/>
-          <a:p>
-            <a:pPr algn="ctr" indent="0" marL="0">
-              <a:buNone/>
-            </a:pPr>
-            <a:r>
-              <a:rPr lang="en-US" sz="750" i="1" dirty="0">
-                <a:solidFill>
-                  <a:srgbClr val="0E7A54"/>
-                </a:solidFill>
-                <a:latin typeface="Arial" pitchFamily="34" charset="0"/>
-                <a:ea typeface="Arial" pitchFamily="34" charset="-122"/>
-                <a:cs typeface="Arial" pitchFamily="34" charset="-120"/>
-              </a:rPr>
-              <a:t>entra (refresco 2012, con 0–1 año)</a:t>
-            </a:r>
-            <a:endParaRPr lang="en-US" sz="750" dirty="0"/>
-          </a:p>
-        </p:txBody>
-      </p:sp>
-      <p:sp>
-        <p:nvSpPr>
-          <p:cNvPr id="41" name="Text 39"/>
-          <p:cNvSpPr txBox="1"/>
-          <p:nvPr/>
-        </p:nvSpPr>
-        <p:spPr>
-          <a:xfrm>
-            <a:off x="2651760" y="4224528"/>
-            <a:ext cx="9052560" cy="182880"/>
-          </a:xfrm>
-          <a:prstGeom prst="rect">
-            <a:avLst/>
-          </a:prstGeom>
-          <a:noFill/>
-          <a:ln/>
-        </p:spPr>
-        <p:txBody>
-          <a:bodyPr wrap="square" lIns="0" tIns="0" rIns="0" bIns="0" rtlCol="0" anchor="ctr"/>
-          <a:lstStyle/>
-          <a:p>
-            <a:pPr algn="l" indent="0" marL="0">
-              <a:buNone/>
-            </a:pPr>
-            <a:r>
-              <a:rPr lang="en-US" sz="850" i="1" dirty="0">
-                <a:solidFill>
-                  <a:srgbClr val="898781"/>
-                </a:solidFill>
-                <a:latin typeface="Arial" pitchFamily="34" charset="0"/>
-                <a:ea typeface="Arial" pitchFamily="34" charset="-122"/>
-                <a:cs typeface="Arial" pitchFamily="34" charset="-120"/>
-              </a:rPr>
-              <a:t>Las barras empiezan al NACER; el anillo marca la entrada a la ELPI y el punto lleno, la medición que usa la regresión.</a:t>
-            </a:r>
-            <a:endParaRPr lang="en-US" sz="850" dirty="0"/>
-          </a:p>
-        </p:txBody>
-      </p:sp>
-      <p:sp>
-        <p:nvSpPr>
-          <p:cNvPr id="42" name="Shape 40"/>
-          <p:cNvSpPr/>
-          <p:nvPr/>
-        </p:nvSpPr>
-        <p:spPr>
-          <a:xfrm>
-            <a:off x="8485632" y="2231136"/>
-            <a:ext cx="2432304" cy="658368"/>
+            <a:off x="457200" y="4754880"/>
+            <a:ext cx="3630168" cy="1481328"/>
           </a:xfrm>
           <a:prstGeom prst="roundRect">
             <a:avLst>
-              <a:gd name="adj" fmla="val 6944"/>
-            </a:avLst>
-          </a:prstGeom>
-          <a:solidFill>
-            <a:srgbClr val="FFFFFF"/>
-          </a:solidFill>
-          <a:ln w="12700">
-            <a:solidFill>
-              <a:srgbClr val="1E3D5C"/>
-            </a:solidFill>
-            <a:prstDash val="dash"/>
-          </a:ln>
-        </p:spPr>
-      </p:sp>
-      <p:sp>
-        <p:nvSpPr>
-          <p:cNvPr id="43" name="Text 41"/>
-          <p:cNvSpPr txBox="1"/>
-          <p:nvPr/>
-        </p:nvSpPr>
-        <p:spPr>
-          <a:xfrm>
-            <a:off x="8577072" y="2286000"/>
-            <a:ext cx="2267712" cy="566928"/>
-          </a:xfrm>
-          <a:prstGeom prst="rect">
-            <a:avLst/>
-          </a:prstGeom>
-          <a:noFill/>
-          <a:ln/>
-        </p:spPr>
-        <p:txBody>
-          <a:bodyPr wrap="square" lIns="0" tIns="0" rIns="0" bIns="0" rtlCol="0" anchor="t"/>
-          <a:lstStyle/>
-          <a:p>
-            <a:pPr algn="l" indent="0" marL="0">
-              <a:lnSpc>
-                <a:spcPct val="102000"/>
-              </a:lnSpc>
-              <a:buNone/>
-            </a:pPr>
-            <a:r>
-              <a:rPr lang="en-US" sz="780" b="1" dirty="0">
-                <a:solidFill>
-                  <a:srgbClr val="1E3D5C"/>
-                </a:solidFill>
-                <a:latin typeface="Arial" pitchFamily="34" charset="0"/>
-                <a:ea typeface="Arial" pitchFamily="34" charset="-122"/>
-                <a:cs typeface="Arial" pitchFamily="34" charset="-120"/>
-              </a:rPr>
-              <a:t>La ventana fina: </a:t>
-            </a:r>
-            <a:pPr algn="l" indent="0" marL="0">
-              <a:lnSpc>
-                <a:spcPct val="102000"/>
-              </a:lnSpc>
-              <a:buNone/>
-            </a:pPr>
-            <a:r>
-              <a:rPr lang="en-US" sz="780" dirty="0">
-                <a:solidFill>
-                  <a:srgbClr val="52514E"/>
-                </a:solidFill>
-                <a:latin typeface="Arial" pitchFamily="34" charset="0"/>
-                <a:ea typeface="Arial" pitchFamily="34" charset="-122"/>
-                <a:cs typeface="Arial" pitchFamily="34" charset="-120"/>
-              </a:rPr>
-              <a:t>nacidos ≤2010 vs 2011 — 12 meses aparte. A los de 2011 se les testea en 2017, a la misma edad. Gillmore C.31: −0,25 DE.</a:t>
-            </a:r>
-            <a:endParaRPr lang="en-US" sz="780" dirty="0"/>
-          </a:p>
-        </p:txBody>
-      </p:sp>
-      <p:sp>
-        <p:nvSpPr>
-          <p:cNvPr id="44" name="Shape 42"/>
-          <p:cNvSpPr/>
-          <p:nvPr/>
-        </p:nvSpPr>
-        <p:spPr>
-          <a:xfrm>
-            <a:off x="457200" y="4617720"/>
-            <a:ext cx="3630168" cy="1645920"/>
-          </a:xfrm>
-          <a:prstGeom prst="roundRect">
-            <a:avLst>
-              <a:gd name="adj" fmla="val 3889"/>
+              <a:gd name="adj" fmla="val 4321"/>
             </a:avLst>
           </a:prstGeom>
           <a:solidFill>
@@ -9826,30 +10296,30 @@
       </p:sp>
       <p:sp>
         <p:nvSpPr>
-          <p:cNvPr id="45" name="Text 43"/>
-          <p:cNvSpPr txBox="1"/>
-          <p:nvPr/>
-        </p:nvSpPr>
-        <p:spPr>
-          <a:xfrm>
-            <a:off x="603504" y="4727448"/>
-            <a:ext cx="3337560" cy="219456"/>
-          </a:xfrm>
-          <a:prstGeom prst="rect">
-            <a:avLst/>
-          </a:prstGeom>
-          <a:noFill/>
-          <a:ln/>
-        </p:spPr>
-        <p:txBody>
-          <a:bodyPr wrap="square" lIns="0" tIns="0" rIns="0" bIns="0" rtlCol="0" anchor="ctr"/>
-          <a:lstStyle/>
-          <a:p>
-            <a:pPr algn="l" indent="0" marL="0">
-              <a:buNone/>
-            </a:pPr>
-            <a:r>
-              <a:rPr lang="en-US" sz="1050" b="1" dirty="0">
+          <p:cNvPr id="59" name="Text 57"/>
+          <p:cNvSpPr txBox="1"/>
+          <p:nvPr/>
+        </p:nvSpPr>
+        <p:spPr>
+          <a:xfrm>
+            <a:off x="603504" y="4846320"/>
+            <a:ext cx="3337560" cy="201168"/>
+          </a:xfrm>
+          <a:prstGeom prst="rect">
+            <a:avLst/>
+          </a:prstGeom>
+          <a:noFill/>
+          <a:ln/>
+        </p:spPr>
+        <p:txBody>
+          <a:bodyPr wrap="square" lIns="0" tIns="0" rIns="0" bIns="0" rtlCol="0" anchor="ctr"/>
+          <a:lstStyle/>
+          <a:p>
+            <a:pPr algn="l" indent="0" marL="0">
+              <a:buNone/>
+            </a:pPr>
+            <a:r>
+              <a:rPr lang="en-US" sz="1000" b="1" dirty="0">
                 <a:solidFill>
                   <a:srgbClr val="1E3D5C"/>
                 </a:solidFill>
@@ -9859,20 +10329,20 @@
               </a:rPr>
               <a:t>CORTO PLAZO · 2 años</a:t>
             </a:r>
-            <a:endParaRPr lang="en-US" sz="1050" dirty="0"/>
-          </a:p>
-        </p:txBody>
-      </p:sp>
-      <p:sp>
-        <p:nvSpPr>
-          <p:cNvPr id="46" name="Text 44"/>
-          <p:cNvSpPr txBox="1"/>
-          <p:nvPr/>
-        </p:nvSpPr>
-        <p:spPr>
-          <a:xfrm>
-            <a:off x="603504" y="4983480"/>
-            <a:ext cx="3337560" cy="1188720"/>
+            <a:endParaRPr lang="en-US" sz="1000" dirty="0"/>
+          </a:p>
+        </p:txBody>
+      </p:sp>
+      <p:sp>
+        <p:nvSpPr>
+          <p:cNvPr id="60" name="Text 58"/>
+          <p:cNvSpPr txBox="1"/>
+          <p:nvPr/>
+        </p:nvSpPr>
+        <p:spPr>
+          <a:xfrm>
+            <a:off x="603504" y="5084064"/>
+            <a:ext cx="3337560" cy="1097280"/>
           </a:xfrm>
           <a:prstGeom prst="rect">
             <a:avLst/>
@@ -9891,7 +10361,7 @@
               <a:buNone/>
             </a:pPr>
             <a:r>
-              <a:rPr lang="en-US" sz="930" dirty="0">
+              <a:rPr lang="en-US" sz="900" dirty="0">
                 <a:solidFill>
                   <a:srgbClr val="52514E"/>
                 </a:solidFill>
@@ -9899,26 +10369,26 @@
                 <a:ea typeface="Arial" pitchFamily="34" charset="-122"/>
                 <a:cs typeface="Arial" pitchFamily="34" charset="-120"/>
               </a:rPr>
-              <a:t>Tratados con 2–6 años (ola 2012) vs. controles con 2–6 años (ola 2017): misma edad, distinta ola — la diferencia de ola la absorbe ηw.</a:t>
-            </a:r>
-            <a:endParaRPr lang="en-US" sz="930" dirty="0"/>
-          </a:p>
-        </p:txBody>
-      </p:sp>
-      <p:sp>
-        <p:nvSpPr>
-          <p:cNvPr id="47" name="Shape 45"/>
+              <a:t>Filas 1–2 medidas en la ola 2012 (2–6) vs. filas 3–4 medidas en la ola 2017 (2–6): misma edad, distinta ola — la absorbe ηw.</a:t>
+            </a:r>
+            <a:endParaRPr lang="en-US" sz="900" dirty="0"/>
+          </a:p>
+        </p:txBody>
+      </p:sp>
+      <p:sp>
+        <p:nvSpPr>
+          <p:cNvPr id="61" name="Shape 59"/>
           <p:cNvSpPr/>
           <p:nvPr/>
         </p:nvSpPr>
         <p:spPr>
           <a:xfrm>
-            <a:off x="4270248" y="4617720"/>
-            <a:ext cx="3630168" cy="1645920"/>
+            <a:off x="4270248" y="4754880"/>
+            <a:ext cx="3630168" cy="1481328"/>
           </a:xfrm>
           <a:prstGeom prst="roundRect">
             <a:avLst>
-              <a:gd name="adj" fmla="val 3889"/>
+              <a:gd name="adj" fmla="val 4321"/>
             </a:avLst>
           </a:prstGeom>
           <a:solidFill>
@@ -9929,30 +10399,30 @@
       </p:sp>
       <p:sp>
         <p:nvSpPr>
-          <p:cNvPr id="48" name="Text 46"/>
-          <p:cNvSpPr txBox="1"/>
-          <p:nvPr/>
-        </p:nvSpPr>
-        <p:spPr>
-          <a:xfrm>
-            <a:off x="4416552" y="4727448"/>
-            <a:ext cx="3337560" cy="219456"/>
-          </a:xfrm>
-          <a:prstGeom prst="rect">
-            <a:avLst/>
-          </a:prstGeom>
-          <a:noFill/>
-          <a:ln/>
-        </p:spPr>
-        <p:txBody>
-          <a:bodyPr wrap="square" lIns="0" tIns="0" rIns="0" bIns="0" rtlCol="0" anchor="ctr"/>
-          <a:lstStyle/>
-          <a:p>
-            <a:pPr algn="l" indent="0" marL="0">
-              <a:buNone/>
-            </a:pPr>
-            <a:r>
-              <a:rPr lang="en-US" sz="1050" b="1" dirty="0">
+          <p:cNvPr id="62" name="Text 60"/>
+          <p:cNvSpPr txBox="1"/>
+          <p:nvPr/>
+        </p:nvSpPr>
+        <p:spPr>
+          <a:xfrm>
+            <a:off x="4416552" y="4846320"/>
+            <a:ext cx="3337560" cy="201168"/>
+          </a:xfrm>
+          <a:prstGeom prst="rect">
+            <a:avLst/>
+          </a:prstGeom>
+          <a:noFill/>
+          <a:ln/>
+        </p:spPr>
+        <p:txBody>
+          <a:bodyPr wrap="square" lIns="0" tIns="0" rIns="0" bIns="0" rtlCol="0" anchor="ctr"/>
+          <a:lstStyle/>
+          <a:p>
+            <a:pPr algn="l" indent="0" marL="0">
+              <a:buNone/>
+            </a:pPr>
+            <a:r>
+              <a:rPr lang="en-US" sz="1000" b="1" dirty="0">
                 <a:solidFill>
                   <a:srgbClr val="1E3D5C"/>
                 </a:solidFill>
@@ -9962,20 +10432,20 @@
               </a:rPr>
               <a:t>MEDIANO PLAZO · 7 años</a:t>
             </a:r>
-            <a:endParaRPr lang="en-US" sz="1050" dirty="0"/>
-          </a:p>
-        </p:txBody>
-      </p:sp>
-      <p:sp>
-        <p:nvSpPr>
-          <p:cNvPr id="49" name="Text 47"/>
-          <p:cNvSpPr txBox="1"/>
-          <p:nvPr/>
-        </p:nvSpPr>
-        <p:spPr>
-          <a:xfrm>
-            <a:off x="4416552" y="4983480"/>
-            <a:ext cx="3337560" cy="1188720"/>
+            <a:endParaRPr lang="en-US" sz="1000" dirty="0"/>
+          </a:p>
+        </p:txBody>
+      </p:sp>
+      <p:sp>
+        <p:nvSpPr>
+          <p:cNvPr id="63" name="Text 61"/>
+          <p:cNvSpPr txBox="1"/>
+          <p:nvPr/>
+        </p:nvSpPr>
+        <p:spPr>
+          <a:xfrm>
+            <a:off x="4416552" y="5084064"/>
+            <a:ext cx="3337560" cy="1097280"/>
           </a:xfrm>
           <a:prstGeom prst="rect">
             <a:avLst/>
@@ -9994,7 +10464,7 @@
               <a:buNone/>
             </a:pPr>
             <a:r>
-              <a:rPr lang="en-US" sz="930" dirty="0">
+              <a:rPr lang="en-US" sz="900" dirty="0">
                 <a:solidFill>
                   <a:srgbClr val="52514E"/>
                 </a:solidFill>
@@ -10002,26 +10472,26 @@
                 <a:ea typeface="Arial" pitchFamily="34" charset="-122"/>
                 <a:cs typeface="Arial" pitchFamily="34" charset="-120"/>
               </a:rPr>
-              <a:t>Tratados 7–11 vs. controles 2–6, todos en la ola 2017: misma ola, distinta edad — tests normados por edad (+ z por tramo).</a:t>
-            </a:r>
-            <a:endParaRPr lang="en-US" sz="930" dirty="0"/>
-          </a:p>
-        </p:txBody>
-      </p:sp>
-      <p:sp>
-        <p:nvSpPr>
-          <p:cNvPr id="50" name="Shape 48"/>
+              <a:t>Filas 1–2 (6–12) vs. filas 3–4 (2–6), todos en la ola 2017: misma ola, distinta edad — tests normados por edad.</a:t>
+            </a:r>
+            <a:endParaRPr lang="en-US" sz="900" dirty="0"/>
+          </a:p>
+        </p:txBody>
+      </p:sp>
+      <p:sp>
+        <p:nvSpPr>
+          <p:cNvPr id="64" name="Shape 62"/>
           <p:cNvSpPr/>
           <p:nvPr/>
         </p:nvSpPr>
         <p:spPr>
           <a:xfrm>
-            <a:off x="8083296" y="4617720"/>
-            <a:ext cx="3630168" cy="1645920"/>
+            <a:off x="8083296" y="4754880"/>
+            <a:ext cx="3630168" cy="1481328"/>
           </a:xfrm>
           <a:prstGeom prst="roundRect">
             <a:avLst>
-              <a:gd name="adj" fmla="val 3889"/>
+              <a:gd name="adj" fmla="val 4321"/>
             </a:avLst>
           </a:prstGeom>
           <a:solidFill>
@@ -10032,30 +10502,30 @@
       </p:sp>
       <p:sp>
         <p:nvSpPr>
-          <p:cNvPr id="51" name="Text 49"/>
-          <p:cNvSpPr txBox="1"/>
-          <p:nvPr/>
-        </p:nvSpPr>
-        <p:spPr>
-          <a:xfrm>
-            <a:off x="8229600" y="4727448"/>
-            <a:ext cx="3337560" cy="219456"/>
-          </a:xfrm>
-          <a:prstGeom prst="rect">
-            <a:avLst/>
-          </a:prstGeom>
-          <a:noFill/>
-          <a:ln/>
-        </p:spPr>
-        <p:txBody>
-          <a:bodyPr wrap="square" lIns="0" tIns="0" rIns="0" bIns="0" rtlCol="0" anchor="ctr"/>
-          <a:lstStyle/>
-          <a:p>
-            <a:pPr algn="l" indent="0" marL="0">
-              <a:buNone/>
-            </a:pPr>
-            <a:r>
-              <a:rPr lang="en-US" sz="1050" b="1" dirty="0">
+          <p:cNvPr id="65" name="Text 63"/>
+          <p:cNvSpPr txBox="1"/>
+          <p:nvPr/>
+        </p:nvSpPr>
+        <p:spPr>
+          <a:xfrm>
+            <a:off x="8229600" y="4846320"/>
+            <a:ext cx="3337560" cy="201168"/>
+          </a:xfrm>
+          <a:prstGeom prst="rect">
+            <a:avLst/>
+          </a:prstGeom>
+          <a:noFill/>
+          <a:ln/>
+        </p:spPr>
+        <p:txBody>
+          <a:bodyPr wrap="square" lIns="0" tIns="0" rIns="0" bIns="0" rtlCol="0" anchor="ctr"/>
+          <a:lstStyle/>
+          <a:p>
+            <a:pPr algn="l" indent="0" marL="0">
+              <a:buNone/>
+            </a:pPr>
+            <a:r>
+              <a:rPr lang="en-US" sz="1000" b="1" dirty="0">
                 <a:solidFill>
                   <a:srgbClr val="1E3D5C"/>
                 </a:solidFill>
@@ -10065,20 +10535,20 @@
               </a:rPr>
               <a:t>LARGO PLAZO · 14 años (nuestro)</a:t>
             </a:r>
-            <a:endParaRPr lang="en-US" sz="1050" dirty="0"/>
-          </a:p>
-        </p:txBody>
-      </p:sp>
-      <p:sp>
-        <p:nvSpPr>
-          <p:cNvPr id="52" name="Text 50"/>
-          <p:cNvSpPr txBox="1"/>
-          <p:nvPr/>
-        </p:nvSpPr>
-        <p:spPr>
-          <a:xfrm>
-            <a:off x="8229600" y="4983480"/>
-            <a:ext cx="3337560" cy="1188720"/>
+            <a:endParaRPr lang="en-US" sz="1000" dirty="0"/>
+          </a:p>
+        </p:txBody>
+      </p:sp>
+      <p:sp>
+        <p:nvSpPr>
+          <p:cNvPr id="66" name="Text 64"/>
+          <p:cNvSpPr txBox="1"/>
+          <p:nvPr/>
+        </p:nvSpPr>
+        <p:spPr>
+          <a:xfrm>
+            <a:off x="8229600" y="5084064"/>
+            <a:ext cx="3337560" cy="1097280"/>
           </a:xfrm>
           <a:prstGeom prst="rect">
             <a:avLst/>
@@ -10097,7 +10567,7 @@
               <a:buNone/>
             </a:pPr>
             <a:r>
-              <a:rPr lang="en-US" sz="930" dirty="0">
+              <a:rPr lang="en-US" sz="900" dirty="0">
                 <a:solidFill>
                   <a:srgbClr val="52514E"/>
                 </a:solidFill>
@@ -10105,15 +10575,15 @@
                 <a:ea typeface="Arial" pitchFamily="34" charset="-122"/>
                 <a:cs typeface="Arial" pitchFamily="34" charset="-120"/>
               </a:rPr>
-              <a:t>Tratados 14–18 en la ola 2024. El control NO fue re-entrevistado: se importa de la ola 2017 (CBCL2, TVIP) — y para PHQ/GAD no existe en ninguna ola.</a:t>
-            </a:r>
-            <a:endParaRPr lang="en-US" sz="930" dirty="0"/>
-          </a:p>
-        </p:txBody>
-      </p:sp>
-      <p:sp>
-        <p:nvSpPr>
-          <p:cNvPr id="53" name="Text 51"/>
+              <a:t>Solo la fila 1 llega a 2024 (14–18). El control se importa de la ola 2017 (CBCL2, TVIP); para PHQ/GAD no existe en ninguna ola.</a:t>
+            </a:r>
+            <a:endParaRPr lang="en-US" sz="900" dirty="0"/>
+          </a:p>
+        </p:txBody>
+      </p:sp>
+      <p:sp>
+        <p:nvSpPr>
+          <p:cNvPr id="67" name="Text 65"/>
           <p:cNvSpPr txBox="1"/>
           <p:nvPr/>
         </p:nvSpPr>

</xml_diff>